<commit_message>
Intro deck 4p v2: cover only, re.feeel oral care page, company+contact page
Co-Authored-By: Claude Opus 5.5 <noreply@anthropic.com>
Claude-Session: https://claude.ai/code/session_015n8jMjDnrfSzm1nCEpX34q
</commit_message>
<xml_diff>
--- a/launch/rs/design/deck-intro/rndmakers-rharashoe-intro-4p.pptx
+++ b/launch/rs/design/deck-intro/rndmakers-rharashoe-intro-4p.pptx
@@ -110,22 +110,22 @@
   <p:extLst>
     <p:ext uri="{521415D9-36F7-43E2-AB2F-B90AF26B5E84}">
       <p14:sectionLst xmlns:p14="http://schemas.microsoft.com/office/powerpoint/2010/main">
-        <p14:section name="표지" id="{3f5744e7-c566-194e-007b-b4584b11dda0}">
+        <p14:section name="표지" id="{e74872fa-cad6-357b-3143-dfc3ba30ce7b}">
           <p14:sldIdLst>
             <p14:sldId id="256"/>
           </p14:sldIdLst>
         </p14:section>
-        <p14:section name="알앤디메이커스" id="{fe89f2a4-df15-bf02-eab6-6bc18878f93d}">
+        <p14:section name="re.feeel" id="{02ed238c-99de-496c-5cd5-4a07a1096d93}">
           <p14:sldIdLst>
             <p14:sldId id="257"/>
           </p14:sldIdLst>
         </p14:section>
-        <p14:section name="라라슈" id="{04278398-aa5b-d080-7666-5bbe3a3e257b}">
+        <p14:section name="라라슈" id="{5d1ad566-83d6-00a9-5e6a-588b2fc0905d}">
           <p14:sldIdLst>
             <p14:sldId id="258"/>
           </p14:sldIdLst>
         </p14:section>
-        <p14:section name="함께하기" id="{be2cc5e8-a6bd-0ea9-4cba-d3eb16e6d129}">
+        <p14:section name="알앤디메이커스" id="{81a070ba-a09e-05d3-e44a-9fb26811f460}">
           <p14:sldIdLst>
             <p14:sldId id="259"/>
           </p14:sldIdLst>
@@ -622,7 +622,7 @@
           <a:p>
             <a:r>
               <a:rPr lang="en-US" dirty="0"/>
-              <a:t/>
+              <a:t>출처: Drive refeeel_brand_concept.docx §6 라인업, SALKO 린스컵 소개서(110g·40°·국내 제조). 효능 표현(충치·잇몸·물때 방지) 배제 — 의약외품 아님. CXP의 PEFC/KFCC-CoC는 소재 제조사 인증이라 미표기. 치실 세트가는 회사 소개서(2601ver) 권장가 기준.</a:t>
             </a:r>
             <a:endParaRPr lang="en-US" dirty="0"/>
           </a:p>
@@ -1328,6 +1328,158 @@
 
 <file path=ppt/slideLayouts/slideLayout5.xml><?xml version="1.0" encoding="utf-8"?>
 <p:sldLayout xmlns:a="http://schemas.openxmlformats.org/drawingml/2006/main" xmlns:r="http://schemas.openxmlformats.org/officeDocument/2006/relationships" xmlns:p="http://schemas.openxmlformats.org/presentationml/2006/main" preserve="1">
+  <p:cSld name="IVORY">
+    <p:bg>
+      <p:bgPr>
+        <a:solidFill>
+          <a:srgbClr val="F2EDE1"/>
+        </a:solidFill>
+      </p:bgPr>
+    </p:bg>
+    <p:spTree>
+      <p:nvGrpSpPr>
+        <p:cNvPr id="1" name=""/>
+        <p:cNvGrpSpPr/>
+        <p:nvPr/>
+      </p:nvGrpSpPr>
+      <p:grpSpPr>
+        <a:xfrm>
+          <a:off x="0" y="0"/>
+          <a:ext cx="0" cy="0"/>
+          <a:chOff x="0" y="0"/>
+          <a:chExt cx="0" cy="0"/>
+        </a:xfrm>
+      </p:grpSpPr>
+      <p:sp>
+        <p:nvSpPr>
+          <p:cNvPr id="2" name="Text 0"/>
+          <p:cNvSpPr/>
+          <p:nvPr>
+            <p:ph idx="100" type="title" hasCustomPrompt="1"/>
+          </p:nvPr>
+        </p:nvSpPr>
+        <p:spPr>
+          <a:xfrm>
+            <a:off x="594360" y="749808"/>
+            <a:ext cx="11002975" cy="685800"/>
+          </a:xfrm>
+          <a:prstGeom prst="rect">
+            <a:avLst/>
+          </a:prstGeom>
+          <a:noFill/>
+          <a:ln/>
+        </p:spPr>
+        <p:txBody>
+          <a:bodyPr wrap="square" rtlCol="0"/>
+          <a:lstStyle>
+            <a:lvl1pPr algn="l" indent="0" marL="0">
+              <a:buNone/>
+              <a:defRPr lang="en-US" sz="3000" b="1" dirty="0">
+                <a:solidFill>
+                  <a:srgbClr val="1F472C"/>
+                </a:solidFill>
+              </a:defRPr>
+            </a:lvl1pPr>
+          </a:lstStyle>
+          <a:p>
+            <a:pPr algn="l" indent="0" marL="0">
+              <a:buNone/>
+            </a:pPr>
+            <a:endParaRPr lang="en-US" sz="3000" dirty="0"/>
+          </a:p>
+        </p:txBody>
+      </p:sp>
+      <p:sp>
+        <p:nvSpPr>
+          <p:cNvPr id="3" name="Text 0"/>
+          <p:cNvSpPr/>
+          <p:nvPr/>
+        </p:nvSpPr>
+        <p:spPr>
+          <a:xfrm>
+            <a:off x="594360" y="6400800"/>
+            <a:ext cx="4572000" cy="228600"/>
+          </a:xfrm>
+          <a:prstGeom prst="rect">
+            <a:avLst/>
+          </a:prstGeom>
+          <a:noFill/>
+          <a:ln/>
+        </p:spPr>
+        <p:txBody>
+          <a:bodyPr wrap="square" lIns="0" tIns="0" rIns="0" bIns="0" rtlCol="0" anchor="ctr"/>
+          <a:lstStyle/>
+          <a:p>
+            <a:pPr indent="0" marL="0">
+              <a:buNone/>
+            </a:pPr>
+            <a:r>
+              <a:rPr lang="en-US" sz="800" spc="300" kern="0" dirty="0">
+                <a:solidFill>
+                  <a:srgbClr val="6B6B5E"/>
+                </a:solidFill>
+              </a:rPr>
+              <a:t>R&amp;D MAKERS  ×  RhaRa Shoe</a:t>
+            </a:r>
+            <a:endParaRPr lang="en-US" sz="800" dirty="0"/>
+          </a:p>
+        </p:txBody>
+      </p:sp>
+      <p:sp>
+        <p:nvSpPr>
+          <p:cNvPr id="25" name="Slide Number Placeholder 0"/>
+          <p:cNvSpPr>
+            <a:spLocks noGrp="1"/>
+          </p:cNvSpPr>
+          <p:nvPr>
+            <p:ph type="sldNum" sz="quarter" idx="4294967295"/>
+          </p:nvPr>
+        </p:nvSpPr>
+        <p:spPr>
+          <a:xfrm>
+            <a:off x="11048695" y="6400800"/>
+            <a:ext cx="548640" cy="228600"/>
+          </a:xfrm>
+          <a:prstGeom prst="rect">
+            <a:avLst/>
+          </a:prstGeom>
+          <a:extLst>
+            <a:ext uri="{C572A759-6A51-4108-AA02-DFA0A04FC94B}">
+              <ma14:wrappingTextBoxFlag xmlns:ma14="http://schemas.microsoft.com/office/mac/drawingml/2011/main" val="0"/>
+            </a:ext>
+          </a:extLst>
+        </p:spPr>
+        <p:txBody>
+          <a:bodyPr/>
+          <a:lstStyle>
+            <a:lvl1pPr>
+              <a:defRPr sz="800">
+                <a:solidFill>
+                  <a:srgbClr val="6B6B5E"/>
+                </a:solidFill>
+              </a:defRPr>
+            </a:lvl1pPr>
+          </a:lstStyle>
+          <a:p>
+            <a:pPr algn="r"/>
+            <a:fld id="{F7021451-1387-4CA6-816F-3879F97B5CBC}" type="slidenum">
+              <a:rPr b="0" lang="en-US"/>
+              <a:t>1005</a:t>
+            </a:fld>
+            <a:endParaRPr lang="en-US"/>
+          </a:p>
+        </p:txBody>
+      </p:sp>
+    </p:spTree>
+  </p:cSld>
+  <p:clrMapOvr>
+    <a:masterClrMapping/>
+  </p:clrMapOvr>
+</p:sldLayout>
+</file>
+
+<file path=ppt/slideLayouts/slideLayout6.xml><?xml version="1.0" encoding="utf-8"?>
+<p:sldLayout xmlns:a="http://schemas.openxmlformats.org/drawingml/2006/main" xmlns:r="http://schemas.openxmlformats.org/officeDocument/2006/relationships" xmlns:p="http://schemas.openxmlformats.org/presentationml/2006/main" preserve="1">
   <p:cSld name="BLANK_NAVY">
     <p:bg>
       <p:bgPr>
@@ -1429,6 +1581,7 @@
     <p:sldLayoutId id="2147483651" r:id="rId3"/>
     <p:sldLayoutId id="2147483652" r:id="rId4"/>
     <p:sldLayoutId id="2147483653" r:id="rId5"/>
+    <p:sldLayoutId id="2147483654" r:id="rId6"/>
   </p:sldLayoutIdLst>
   <p:hf sldNum="0" hdr="0" ftr="0" dt="0"/>
   <p:txStyles>
@@ -1781,8 +1934,8 @@
         </p:nvSpPr>
         <p:spPr>
           <a:xfrm>
-            <a:off x="4206240" y="1234440"/>
-            <a:ext cx="411480" cy="411480"/>
+            <a:off x="7498080" y="1463040"/>
+            <a:ext cx="502920" cy="502920"/>
           </a:xfrm>
           <a:prstGeom prst="ellipse">
             <a:avLst/>
@@ -1795,14 +1948,54 @@
       </p:sp>
       <p:sp>
         <p:nvSpPr>
-          <p:cNvPr id="5" name="라임 타깃"/>
+          <p:cNvPr id="5" name="코랄 도넛"/>
           <p:cNvSpPr/>
           <p:nvPr/>
         </p:nvSpPr>
         <p:spPr>
           <a:xfrm>
-            <a:off x="5074920" y="1051560"/>
-            <a:ext cx="1188720" cy="1188720"/>
+            <a:off x="8503920" y="3840480"/>
+            <a:ext cx="914400" cy="914400"/>
+          </a:xfrm>
+          <a:prstGeom prst="ellipse">
+            <a:avLst/>
+          </a:prstGeom>
+          <a:solidFill>
+            <a:schemeClr val="accent2"/>
+          </a:solidFill>
+          <a:ln/>
+        </p:spPr>
+      </p:sp>
+      <p:sp>
+        <p:nvSpPr>
+          <p:cNvPr id="6" name="도넛 속"/>
+          <p:cNvSpPr/>
+          <p:nvPr/>
+        </p:nvSpPr>
+        <p:spPr>
+          <a:xfrm>
+            <a:off x="8796528" y="4133088"/>
+            <a:ext cx="329184" cy="329184"/>
+          </a:xfrm>
+          <a:prstGeom prst="ellipse">
+            <a:avLst/>
+          </a:prstGeom>
+          <a:solidFill>
+            <a:srgbClr val="181478"/>
+          </a:solidFill>
+          <a:ln/>
+        </p:spPr>
+      </p:sp>
+      <p:sp>
+        <p:nvSpPr>
+          <p:cNvPr id="7" name="라임 타깃"/>
+          <p:cNvSpPr/>
+          <p:nvPr/>
+        </p:nvSpPr>
+        <p:spPr>
+          <a:xfrm>
+            <a:off x="9144000" y="1188720"/>
+            <a:ext cx="2194560" cy="2194560"/>
           </a:xfrm>
           <a:prstGeom prst="ellipse">
             <a:avLst/>
@@ -1815,14 +2008,14 @@
       </p:sp>
       <p:sp>
         <p:nvSpPr>
-          <p:cNvPr id="6" name="타깃 속"/>
+          <p:cNvPr id="8" name="타깃 속"/>
           <p:cNvSpPr/>
           <p:nvPr/>
         </p:nvSpPr>
         <p:spPr>
           <a:xfrm>
-            <a:off x="5376672" y="1353312"/>
-            <a:ext cx="585216" cy="585216"/>
+            <a:off x="9692640" y="1737360"/>
+            <a:ext cx="1097280" cy="1097280"/>
           </a:xfrm>
           <a:prstGeom prst="ellipse">
             <a:avLst/>
@@ -1835,14 +2028,14 @@
       </p:sp>
       <p:sp>
         <p:nvSpPr>
-          <p:cNvPr id="7" name="타깃 중심"/>
+          <p:cNvPr id="9" name="타깃 중심"/>
           <p:cNvSpPr/>
           <p:nvPr/>
         </p:nvSpPr>
         <p:spPr>
           <a:xfrm>
-            <a:off x="5541264" y="1517904"/>
-            <a:ext cx="256032" cy="256032"/>
+            <a:off x="9994392" y="2039112"/>
+            <a:ext cx="493776" cy="493776"/>
           </a:xfrm>
           <a:prstGeom prst="ellipse">
             <a:avLst/>
@@ -1855,14 +2048,14 @@
       </p:sp>
       <p:sp>
         <p:nvSpPr>
-          <p:cNvPr id="8" name="헤드라인"/>
+          <p:cNvPr id="10" name="헤드라인"/>
           <p:cNvSpPr txBox="1"/>
           <p:nvPr/>
         </p:nvSpPr>
         <p:spPr>
           <a:xfrm>
-            <a:off x="594360" y="2103120"/>
-            <a:ext cx="5669280" cy="2103120"/>
+            <a:off x="594360" y="1828800"/>
+            <a:ext cx="6400800" cy="2377440"/>
           </a:xfrm>
           <a:prstGeom prst="rect">
             <a:avLst/>
@@ -1881,14 +2074,14 @@
               <a:buNone/>
             </a:pPr>
             <a:r>
-              <a:rPr lang="en-US" sz="5400" b="1" dirty="0">
+              <a:rPr lang="en-US" sz="6000" b="1" dirty="0">
                 <a:solidFill>
                   <a:schemeClr val="bg2"/>
                 </a:solidFill>
               </a:rPr>
               <a:t>남은 것의</a:t>
             </a:r>
-            <a:endParaRPr lang="en-US" sz="5400" dirty="0"/>
+            <a:endParaRPr lang="en-US" sz="6000" dirty="0"/>
           </a:p>
           <a:p>
             <a:pPr indent="0" marL="0">
@@ -1898,27 +2091,27 @@
               <a:buNone/>
             </a:pPr>
             <a:r>
-              <a:rPr lang="en-US" sz="5400" b="1" dirty="0">
+              <a:rPr lang="en-US" sz="6000" b="1" dirty="0">
                 <a:solidFill>
                   <a:schemeClr val="bg2"/>
                 </a:solidFill>
               </a:rPr>
               <a:t>다음 모양.</a:t>
             </a:r>
-            <a:endParaRPr lang="en-US" sz="5400" dirty="0"/>
-          </a:p>
-        </p:txBody>
-      </p:sp>
-      <p:sp>
-        <p:nvSpPr>
-          <p:cNvPr id="9" name="부제"/>
+            <a:endParaRPr lang="en-US" sz="6000" dirty="0"/>
+          </a:p>
+        </p:txBody>
+      </p:sp>
+      <p:sp>
+        <p:nvSpPr>
+          <p:cNvPr id="11" name="부제"/>
           <p:cNvSpPr txBox="1"/>
           <p:nvPr/>
         </p:nvSpPr>
         <p:spPr>
           <a:xfrm>
             <a:off x="594360" y="4434840"/>
-            <a:ext cx="5669280" cy="731520"/>
+            <a:ext cx="6858000" cy="731520"/>
           </a:xfrm>
           <a:prstGeom prst="rect">
             <a:avLst/>
@@ -1937,14 +2130,14 @@
               <a:buNone/>
             </a:pPr>
             <a:r>
-              <a:rPr lang="en-US" sz="1350" dirty="0">
+              <a:rPr lang="en-US" sz="1500" dirty="0">
                 <a:solidFill>
                   <a:schemeClr val="bg1"/>
                 </a:solidFill>
               </a:rPr>
               <a:t>버려지는 소재로 제품을 만드는 제조사, 알앤디메이커스</a:t>
             </a:r>
-            <a:endParaRPr lang="en-US" sz="1350" dirty="0"/>
+            <a:endParaRPr lang="en-US" sz="1500" dirty="0"/>
           </a:p>
           <a:p>
             <a:pPr indent="0" marL="0">
@@ -1954,27 +2147,27 @@
               <a:buNone/>
             </a:pPr>
             <a:r>
-              <a:rPr lang="en-US" sz="1350" dirty="0">
+              <a:rPr lang="en-US" sz="1500" dirty="0">
                 <a:solidFill>
                   <a:schemeClr val="bg1"/>
                 </a:solidFill>
               </a:rPr>
-              <a:t>그리고 서서 일하는 사람들을 위한 새 브랜드, 라라슈</a:t>
-            </a:r>
-            <a:endParaRPr lang="en-US" sz="1350" dirty="0"/>
-          </a:p>
-        </p:txBody>
-      </p:sp>
-      <p:sp>
-        <p:nvSpPr>
-          <p:cNvPr id="10" name="Text 8"/>
+              <a:t>그리고 그 소재로 만든 두 브랜드, re.feeel과 라라슈</a:t>
+            </a:r>
+            <a:endParaRPr lang="en-US" sz="1500" dirty="0"/>
+          </a:p>
+        </p:txBody>
+      </p:sp>
+      <p:sp>
+        <p:nvSpPr>
+          <p:cNvPr id="12" name="하단"/>
           <p:cNvSpPr txBox="1"/>
           <p:nvPr/>
         </p:nvSpPr>
         <p:spPr>
           <a:xfrm>
             <a:off x="594360" y="6080760"/>
-            <a:ext cx="5486400" cy="274320"/>
+            <a:ext cx="6400800" cy="274320"/>
           </a:xfrm>
           <a:prstGeom prst="rect">
             <a:avLst/>
@@ -1995,351 +2188,9 @@
                   <a:srgbClr val="E0E828"/>
                 </a:solidFill>
               </a:rPr>
-              <a:t>㈜알앤디메이커스  ·  RhaRa Shoe 라라슈</a:t>
+              <a:t>㈜알앤디메이커스  ·  re.feeel  ·  RhaRa Shoe 라라슈</a:t>
             </a:r>
             <a:endParaRPr lang="en-US" sz="1100" dirty="0"/>
-          </a:p>
-        </p:txBody>
-      </p:sp>
-      <p:sp>
-        <p:nvSpPr>
-          <p:cNvPr id="11" name="숫자 카드"/>
-          <p:cNvSpPr/>
-          <p:nvPr/>
-        </p:nvSpPr>
-        <p:spPr>
-          <a:xfrm>
-            <a:off x="6903720" y="1234440"/>
-            <a:ext cx="4690872" cy="1371600"/>
-          </a:xfrm>
-          <a:prstGeom prst="roundRect">
-            <a:avLst>
-              <a:gd name="adj" fmla="val 5333"/>
-            </a:avLst>
-          </a:prstGeom>
-          <a:solidFill>
-            <a:schemeClr val="accent5"/>
-          </a:solidFill>
-          <a:ln/>
-        </p:spPr>
-      </p:sp>
-      <p:sp>
-        <p:nvSpPr>
-          <p:cNvPr id="12" name="큰 숫자"/>
-          <p:cNvSpPr txBox="1"/>
-          <p:nvPr/>
-        </p:nvSpPr>
-        <p:spPr>
-          <a:xfrm>
-            <a:off x="7223760" y="1490472"/>
-            <a:ext cx="1737360" cy="822960"/>
-          </a:xfrm>
-          <a:prstGeom prst="rect">
-            <a:avLst/>
-          </a:prstGeom>
-          <a:noFill/>
-          <a:ln/>
-        </p:spPr>
-        <p:txBody>
-          <a:bodyPr wrap="square" lIns="0" tIns="0" rIns="0" bIns="0" rtlCol="0" anchor="ctr"/>
-          <a:lstStyle/>
-          <a:p>
-            <a:pPr indent="0" marL="0">
-              <a:buNone/>
-            </a:pPr>
-            <a:r>
-              <a:rPr lang="en-US" sz="4000" b="1" dirty="0">
-                <a:solidFill>
-                  <a:srgbClr val="E0E828"/>
-                </a:solidFill>
-              </a:rPr>
-              <a:t>2023</a:t>
-            </a:r>
-            <a:endParaRPr lang="en-US" sz="4000" dirty="0"/>
-          </a:p>
-        </p:txBody>
-      </p:sp>
-      <p:sp>
-        <p:nvSpPr>
-          <p:cNvPr id="13" name="설명"/>
-          <p:cNvSpPr txBox="1"/>
-          <p:nvPr/>
-        </p:nvSpPr>
-        <p:spPr>
-          <a:xfrm>
-            <a:off x="8869680" y="1490472"/>
-            <a:ext cx="2606040" cy="822960"/>
-          </a:xfrm>
-          <a:prstGeom prst="rect">
-            <a:avLst/>
-          </a:prstGeom>
-          <a:noFill/>
-          <a:ln/>
-        </p:spPr>
-        <p:txBody>
-          <a:bodyPr wrap="square" lIns="0" tIns="0" rIns="0" bIns="0" rtlCol="0" anchor="ctr"/>
-          <a:lstStyle/>
-          <a:p>
-            <a:pPr indent="0" marL="0">
-              <a:lnSpc>
-                <a:spcPct val="125000"/>
-              </a:lnSpc>
-              <a:buNone/>
-            </a:pPr>
-            <a:r>
-              <a:rPr lang="en-US" sz="1300" dirty="0">
-                <a:solidFill>
-                  <a:schemeClr val="bg1"/>
-                </a:solidFill>
-              </a:rPr>
-              <a:t>법인 창립</a:t>
-            </a:r>
-            <a:endParaRPr lang="en-US" sz="1300" dirty="0"/>
-          </a:p>
-          <a:p>
-            <a:pPr indent="0" marL="0">
-              <a:lnSpc>
-                <a:spcPct val="125000"/>
-              </a:lnSpc>
-              <a:buNone/>
-            </a:pPr>
-            <a:r>
-              <a:rPr lang="en-US" sz="1300" dirty="0">
-                <a:solidFill>
-                  <a:schemeClr val="bg1"/>
-                </a:solidFill>
-              </a:rPr>
-              <a:t>창업진흥원 국가과제 수행</a:t>
-            </a:r>
-            <a:endParaRPr lang="en-US" sz="1300" dirty="0"/>
-          </a:p>
-        </p:txBody>
-      </p:sp>
-      <p:sp>
-        <p:nvSpPr>
-          <p:cNvPr id="14" name="숫자 카드"/>
-          <p:cNvSpPr/>
-          <p:nvPr/>
-        </p:nvSpPr>
-        <p:spPr>
-          <a:xfrm>
-            <a:off x="6903720" y="2834640"/>
-            <a:ext cx="4690872" cy="1371600"/>
-          </a:xfrm>
-          <a:prstGeom prst="roundRect">
-            <a:avLst>
-              <a:gd name="adj" fmla="val 5333"/>
-            </a:avLst>
-          </a:prstGeom>
-          <a:solidFill>
-            <a:schemeClr val="accent5"/>
-          </a:solidFill>
-          <a:ln/>
-        </p:spPr>
-      </p:sp>
-      <p:sp>
-        <p:nvSpPr>
-          <p:cNvPr id="15" name="큰 숫자"/>
-          <p:cNvSpPr txBox="1"/>
-          <p:nvPr/>
-        </p:nvSpPr>
-        <p:spPr>
-          <a:xfrm>
-            <a:off x="7223760" y="3090672"/>
-            <a:ext cx="1737360" cy="822960"/>
-          </a:xfrm>
-          <a:prstGeom prst="rect">
-            <a:avLst/>
-          </a:prstGeom>
-          <a:noFill/>
-          <a:ln/>
-        </p:spPr>
-        <p:txBody>
-          <a:bodyPr wrap="square" lIns="0" tIns="0" rIns="0" bIns="0" rtlCol="0" anchor="ctr"/>
-          <a:lstStyle/>
-          <a:p>
-            <a:pPr indent="0" marL="0">
-              <a:buNone/>
-            </a:pPr>
-            <a:r>
-              <a:rPr lang="en-US" sz="4000" b="1" dirty="0">
-                <a:solidFill>
-                  <a:srgbClr val="E0E828"/>
-                </a:solidFill>
-              </a:rPr>
-              <a:t>전국</a:t>
-            </a:r>
-            <a:endParaRPr lang="en-US" sz="4000" dirty="0"/>
-          </a:p>
-        </p:txBody>
-      </p:sp>
-      <p:sp>
-        <p:nvSpPr>
-          <p:cNvPr id="16" name="설명"/>
-          <p:cNvSpPr txBox="1"/>
-          <p:nvPr/>
-        </p:nvSpPr>
-        <p:spPr>
-          <a:xfrm>
-            <a:off x="8869680" y="3090672"/>
-            <a:ext cx="2606040" cy="822960"/>
-          </a:xfrm>
-          <a:prstGeom prst="rect">
-            <a:avLst/>
-          </a:prstGeom>
-          <a:noFill/>
-          <a:ln/>
-        </p:spPr>
-        <p:txBody>
-          <a:bodyPr wrap="square" lIns="0" tIns="0" rIns="0" bIns="0" rtlCol="0" anchor="ctr"/>
-          <a:lstStyle/>
-          <a:p>
-            <a:pPr indent="0" marL="0">
-              <a:lnSpc>
-                <a:spcPct val="125000"/>
-              </a:lnSpc>
-              <a:buNone/>
-            </a:pPr>
-            <a:r>
-              <a:rPr lang="en-US" sz="1300" dirty="0">
-                <a:solidFill>
-                  <a:schemeClr val="bg1"/>
-                </a:solidFill>
-              </a:rPr>
-              <a:t>다이소 전국 매장 입점</a:t>
-            </a:r>
-            <a:endParaRPr lang="en-US" sz="1300" dirty="0"/>
-          </a:p>
-          <a:p>
-            <a:pPr indent="0" marL="0">
-              <a:lnSpc>
-                <a:spcPct val="125000"/>
-              </a:lnSpc>
-              <a:buNone/>
-            </a:pPr>
-            <a:r>
-              <a:rPr lang="en-US" sz="1300" dirty="0">
-                <a:solidFill>
-                  <a:schemeClr val="bg1"/>
-                </a:solidFill>
-              </a:rPr>
-              <a:t>2023.09~</a:t>
-            </a:r>
-            <a:endParaRPr lang="en-US" sz="1300" dirty="0"/>
-          </a:p>
-        </p:txBody>
-      </p:sp>
-      <p:sp>
-        <p:nvSpPr>
-          <p:cNvPr id="17" name="숫자 카드"/>
-          <p:cNvSpPr/>
-          <p:nvPr/>
-        </p:nvSpPr>
-        <p:spPr>
-          <a:xfrm>
-            <a:off x="6903720" y="4434840"/>
-            <a:ext cx="4690872" cy="1371600"/>
-          </a:xfrm>
-          <a:prstGeom prst="roundRect">
-            <a:avLst>
-              <a:gd name="adj" fmla="val 5333"/>
-            </a:avLst>
-          </a:prstGeom>
-          <a:solidFill>
-            <a:schemeClr val="accent5"/>
-          </a:solidFill>
-          <a:ln/>
-        </p:spPr>
-      </p:sp>
-      <p:sp>
-        <p:nvSpPr>
-          <p:cNvPr id="18" name="큰 숫자"/>
-          <p:cNvSpPr txBox="1"/>
-          <p:nvPr/>
-        </p:nvSpPr>
-        <p:spPr>
-          <a:xfrm>
-            <a:off x="7223760" y="4690872"/>
-            <a:ext cx="1737360" cy="822960"/>
-          </a:xfrm>
-          <a:prstGeom prst="rect">
-            <a:avLst/>
-          </a:prstGeom>
-          <a:noFill/>
-          <a:ln/>
-        </p:spPr>
-        <p:txBody>
-          <a:bodyPr wrap="square" lIns="0" tIns="0" rIns="0" bIns="0" rtlCol="0" anchor="ctr"/>
-          <a:lstStyle/>
-          <a:p>
-            <a:pPr indent="0" marL="0">
-              <a:buNone/>
-            </a:pPr>
-            <a:r>
-              <a:rPr lang="en-US" sz="4000" b="1" dirty="0">
-                <a:solidFill>
-                  <a:srgbClr val="E0E828"/>
-                </a:solidFill>
-              </a:rPr>
-              <a:t>2회</a:t>
-            </a:r>
-            <a:endParaRPr lang="en-US" sz="4000" dirty="0"/>
-          </a:p>
-        </p:txBody>
-      </p:sp>
-      <p:sp>
-        <p:nvSpPr>
-          <p:cNvPr id="19" name="설명"/>
-          <p:cNvSpPr txBox="1"/>
-          <p:nvPr/>
-        </p:nvSpPr>
-        <p:spPr>
-          <a:xfrm>
-            <a:off x="8869680" y="4690872"/>
-            <a:ext cx="2606040" cy="822960"/>
-          </a:xfrm>
-          <a:prstGeom prst="rect">
-            <a:avLst/>
-          </a:prstGeom>
-          <a:noFill/>
-          <a:ln/>
-        </p:spPr>
-        <p:txBody>
-          <a:bodyPr wrap="square" lIns="0" tIns="0" rIns="0" bIns="0" rtlCol="0" anchor="ctr"/>
-          <a:lstStyle/>
-          <a:p>
-            <a:pPr indent="0" marL="0">
-              <a:lnSpc>
-                <a:spcPct val="125000"/>
-              </a:lnSpc>
-              <a:buNone/>
-            </a:pPr>
-            <a:r>
-              <a:rPr lang="en-US" sz="1300" dirty="0">
-                <a:solidFill>
-                  <a:schemeClr val="bg1"/>
-                </a:solidFill>
-              </a:rPr>
-              <a:t>환경부 새활용 지원사업</a:t>
-            </a:r>
-            <a:endParaRPr lang="en-US" sz="1300" dirty="0"/>
-          </a:p>
-          <a:p>
-            <a:pPr indent="0" marL="0">
-              <a:lnSpc>
-                <a:spcPct val="125000"/>
-              </a:lnSpc>
-              <a:buNone/>
-            </a:pPr>
-            <a:r>
-              <a:rPr lang="en-US" sz="1300" dirty="0">
-                <a:solidFill>
-                  <a:schemeClr val="bg1"/>
-                </a:solidFill>
-              </a:rPr>
-              <a:t>2024 · 2026 2차</a:t>
-            </a:r>
-            <a:endParaRPr lang="en-US" sz="1300" dirty="0"/>
           </a:p>
         </p:txBody>
       </p:sp>
@@ -2395,10 +2246,10 @@
             <a:r>
               <a:rPr lang="en-US" sz="1000" b="1" spc="400" kern="0" dirty="0">
                 <a:solidFill>
-                  <a:schemeClr val="accent3"/>
-                </a:solidFill>
-              </a:rPr>
-              <a:t>COMPANY</a:t>
+                  <a:srgbClr val="3F7A52"/>
+                </a:solidFill>
+              </a:rPr>
+              <a:t>RE.FEEEL  ·  ORAL CARE</a:t>
             </a:r>
             <a:endParaRPr lang="en-US" sz="1000" dirty="0"/>
           </a:p>
@@ -2433,10 +2284,10 @@
             <a:r>
               <a:rPr lang="en-US" sz="3000" b="1" dirty="0">
                 <a:solidFill>
-                  <a:schemeClr val="tx1"/>
-                </a:solidFill>
-              </a:rPr>
-              <a:t>소재부터 납품까지, 한 회사에서</a:t>
+                  <a:srgbClr val="1F472C"/>
+                </a:solidFill>
+              </a:rPr>
+              <a:t>생활을 다시 채우다.</a:t>
             </a:r>
             <a:endParaRPr lang="en-US" sz="3000" dirty="0"/>
           </a:p>
@@ -2444,36 +2295,119 @@
       </p:sp>
       <p:sp>
         <p:nvSpPr>
-          <p:cNvPr id="4" name="역량 카드"/>
+          <p:cNvPr id="4" name="브랜드 설명"/>
+          <p:cNvSpPr txBox="1"/>
+          <p:nvPr/>
+        </p:nvSpPr>
+        <p:spPr>
+          <a:xfrm>
+            <a:off x="594360" y="1463040"/>
+            <a:ext cx="8778240" cy="320040"/>
+          </a:xfrm>
+          <a:prstGeom prst="rect">
+            <a:avLst/>
+          </a:prstGeom>
+          <a:noFill/>
+          <a:ln/>
+        </p:spPr>
+        <p:txBody>
+          <a:bodyPr wrap="square" lIns="0" tIns="0" rIns="0" bIns="0" rtlCol="0" anchor="t"/>
+          <a:lstStyle/>
+          <a:p>
+            <a:pPr indent="0" marL="0">
+              <a:buNone/>
+            </a:pPr>
+            <a:r>
+              <a:rPr lang="en-US" sz="1300" dirty="0">
+                <a:solidFill>
+                  <a:srgbClr val="4A4A40"/>
+                </a:solidFill>
+              </a:rPr>
+              <a:t>숲을 가꾸며 솎아낸 간벌재(임업부산물)를 CXP 소재로 바꿔, 매일 쓰는 구강용품으로 만듭니다.</a:t>
+            </a:r>
+            <a:endParaRPr lang="en-US" sz="1300" dirty="0"/>
+          </a:p>
+        </p:txBody>
+      </p:sp>
+      <p:pic>
+        <p:nvPicPr>
+          <p:cNvPr id="5" name="re.feeel 로고" descr="img/refeeel-seal.png">    </p:cNvPr>
+          <p:cNvPicPr>
+            <a:picLocks noChangeAspect="1"/>
+          </p:cNvPicPr>
+          <p:nvPr/>
+        </p:nvPicPr>
+        <p:blipFill>
+          <a:blip r:embed="rId1"/>
+          <a:stretch>
+            <a:fillRect/>
+          </a:stretch>
+        </p:blipFill>
+        <p:spPr>
+          <a:xfrm>
+            <a:off x="10362895" y="320040"/>
+            <a:ext cx="1234440" cy="1259633"/>
+          </a:xfrm>
+          <a:prstGeom prst="rect">
+            <a:avLst/>
+          </a:prstGeom>
+        </p:spPr>
+      </p:pic>
+      <p:sp>
+        <p:nvSpPr>
+          <p:cNvPr id="6" name="제품 카드"/>
           <p:cNvSpPr/>
           <p:nvPr/>
         </p:nvSpPr>
         <p:spPr>
           <a:xfrm>
-            <a:off x="594360" y="1691640"/>
-            <a:ext cx="3545738" cy="1234440"/>
+            <a:off x="594360" y="1965960"/>
+            <a:ext cx="3515258" cy="3657600"/>
           </a:xfrm>
           <a:prstGeom prst="roundRect">
             <a:avLst>
-              <a:gd name="adj" fmla="val 5926"/>
+              <a:gd name="adj" fmla="val 2081"/>
             </a:avLst>
           </a:prstGeom>
           <a:solidFill>
-            <a:schemeClr val="accent4"/>
+            <a:srgbClr val="FFFFFF"/>
           </a:solidFill>
           <a:ln/>
         </p:spPr>
       </p:sp>
-      <p:sp>
-        <p:nvSpPr>
-          <p:cNvPr id="5" name="역량"/>
+      <p:pic>
+        <p:nvPicPr>
+          <p:cNvPr id="7" name="나이스샷 '왕모' 칫솔" descr="img/toothbrush.jpg">    </p:cNvPr>
+          <p:cNvPicPr>
+            <a:picLocks noChangeAspect="1"/>
+          </p:cNvPicPr>
+          <p:nvPr/>
+        </p:nvPicPr>
+        <p:blipFill>
+          <a:blip r:embed="rId2"/>
+          <a:srcRect l="0" r="0" t="0" b="0"/>
+          <a:stretch/>
+        </p:blipFill>
+        <p:spPr>
+          <a:xfrm>
+            <a:off x="731520" y="2103120"/>
+            <a:ext cx="3240938" cy="2148840"/>
+          </a:xfrm>
+          <a:prstGeom prst="rect">
+            <a:avLst/>
+          </a:prstGeom>
+        </p:spPr>
+      </p:pic>
+      <p:sp>
+        <p:nvSpPr>
+          <p:cNvPr id="8" name="제품명"/>
           <p:cNvSpPr txBox="1"/>
           <p:nvPr/>
         </p:nvSpPr>
         <p:spPr>
           <a:xfrm>
-            <a:off x="868680" y="1874520"/>
-            <a:ext cx="2997098" cy="914400"/>
+            <a:off x="868680" y="4434840"/>
+            <a:ext cx="2966618" cy="365760"/>
           </a:xfrm>
           <a:prstGeom prst="rect">
             <a:avLst/>
@@ -2486,72 +2420,131 @@
           <a:lstStyle/>
           <a:p>
             <a:pPr indent="0" marL="0">
+              <a:buNone/>
+            </a:pPr>
+            <a:r>
+              <a:rPr lang="en-US" sz="1600" b="1" dirty="0">
+                <a:solidFill>
+                  <a:srgbClr val="1F472C"/>
+                </a:solidFill>
+              </a:rPr>
+              <a:t>나이스샷 '왕모' 칫솔</a:t>
+            </a:r>
+            <a:endParaRPr lang="en-US" sz="1600" dirty="0"/>
+          </a:p>
+        </p:txBody>
+      </p:sp>
+      <p:sp>
+        <p:nvSpPr>
+          <p:cNvPr id="9" name="제품 설명"/>
+          <p:cNvSpPr txBox="1"/>
+          <p:nvPr/>
+        </p:nvSpPr>
+        <p:spPr>
+          <a:xfrm>
+            <a:off x="868680" y="4846320"/>
+            <a:ext cx="2966618" cy="685800"/>
+          </a:xfrm>
+          <a:prstGeom prst="rect">
+            <a:avLst/>
+          </a:prstGeom>
+          <a:noFill/>
+          <a:ln/>
+        </p:spPr>
+        <p:txBody>
+          <a:bodyPr wrap="square" lIns="0" tIns="0" rIns="0" bIns="0" rtlCol="0" anchor="t"/>
+          <a:lstStyle/>
+          <a:p>
+            <a:pPr indent="0" marL="0">
               <a:lnSpc>
-                <a:spcPct val="125000"/>
+                <a:spcPct val="130000"/>
               </a:lnSpc>
               <a:buNone/>
             </a:pPr>
             <a:r>
-              <a:rPr lang="en-US" sz="1600" b="1" dirty="0">
-                <a:solidFill>
-                  <a:schemeClr val="tx1"/>
-                </a:solidFill>
-              </a:rPr>
-              <a:t>01  소재</a:t>
-            </a:r>
-            <a:endParaRPr lang="en-US" sz="1600" dirty="0"/>
+              <a:rPr lang="en-US" sz="1100" dirty="0">
+                <a:solidFill>
+                  <a:srgbClr val="4A4A40"/>
+                </a:solidFill>
+              </a:rPr>
+              <a:t>CXP 소재 핸들 · 6개입</a:t>
+            </a:r>
+            <a:endParaRPr lang="en-US" sz="1100" dirty="0"/>
           </a:p>
           <a:p>
             <a:pPr indent="0" marL="0">
               <a:lnSpc>
-                <a:spcPct val="125000"/>
+                <a:spcPct val="130000"/>
               </a:lnSpc>
               <a:buNone/>
             </a:pPr>
             <a:r>
-              <a:rPr lang="en-US" sz="1150" dirty="0">
-                <a:solidFill>
-                  <a:schemeClr val="tx2"/>
-                </a:solidFill>
-              </a:rPr>
-              <a:t>실크벽지 PVC · 폐타이어 고무 · CXP 목재 복합소재</a:t>
-            </a:r>
-            <a:endParaRPr lang="en-US" sz="1600" dirty="0"/>
-          </a:p>
-        </p:txBody>
-      </p:sp>
-      <p:sp>
-        <p:nvSpPr>
-          <p:cNvPr id="6" name="역량 카드"/>
+              <a:rPr lang="en-US" sz="1100" dirty="0">
+                <a:solidFill>
+                  <a:srgbClr val="4A4A40"/>
+                </a:solidFill>
+              </a:rPr>
+              <a:t>넓은 헤드 · 이중미세모 / 스파이럴모</a:t>
+            </a:r>
+            <a:endParaRPr lang="en-US" sz="1100" dirty="0"/>
+          </a:p>
+        </p:txBody>
+      </p:sp>
+      <p:sp>
+        <p:nvSpPr>
+          <p:cNvPr id="10" name="제품 카드"/>
           <p:cNvSpPr/>
           <p:nvPr/>
         </p:nvSpPr>
         <p:spPr>
           <a:xfrm>
-            <a:off x="4322978" y="1691640"/>
-            <a:ext cx="3545738" cy="1234440"/>
+            <a:off x="4338218" y="1965960"/>
+            <a:ext cx="3515258" cy="3657600"/>
           </a:xfrm>
           <a:prstGeom prst="roundRect">
             <a:avLst>
-              <a:gd name="adj" fmla="val 5926"/>
+              <a:gd name="adj" fmla="val 2081"/>
             </a:avLst>
           </a:prstGeom>
           <a:solidFill>
-            <a:schemeClr val="accent4"/>
+            <a:srgbClr val="FFFFFF"/>
           </a:solidFill>
           <a:ln/>
         </p:spPr>
       </p:sp>
-      <p:sp>
-        <p:nvSpPr>
-          <p:cNvPr id="7" name="역량"/>
+      <p:pic>
+        <p:nvPicPr>
+          <p:cNvPr id="11" name="칫솔형 치실" descr="img/floss.jpg">    </p:cNvPr>
+          <p:cNvPicPr>
+            <a:picLocks noChangeAspect="1"/>
+          </p:cNvPicPr>
+          <p:nvPr/>
+        </p:nvPicPr>
+        <p:blipFill>
+          <a:blip r:embed="rId3"/>
+          <a:srcRect l="0" r="0" t="0" b="0"/>
+          <a:stretch/>
+        </p:blipFill>
+        <p:spPr>
+          <a:xfrm>
+            <a:off x="4475378" y="2103120"/>
+            <a:ext cx="3240938" cy="2148840"/>
+          </a:xfrm>
+          <a:prstGeom prst="rect">
+            <a:avLst/>
+          </a:prstGeom>
+        </p:spPr>
+      </p:pic>
+      <p:sp>
+        <p:nvSpPr>
+          <p:cNvPr id="12" name="제품명"/>
           <p:cNvSpPr txBox="1"/>
           <p:nvPr/>
         </p:nvSpPr>
         <p:spPr>
           <a:xfrm>
-            <a:off x="4597298" y="1874520"/>
-            <a:ext cx="2997098" cy="914400"/>
+            <a:off x="4612538" y="4434840"/>
+            <a:ext cx="2966618" cy="365760"/>
           </a:xfrm>
           <a:prstGeom prst="rect">
             <a:avLst/>
@@ -2564,72 +2557,131 @@
           <a:lstStyle/>
           <a:p>
             <a:pPr indent="0" marL="0">
+              <a:buNone/>
+            </a:pPr>
+            <a:r>
+              <a:rPr lang="en-US" sz="1600" b="1" dirty="0">
+                <a:solidFill>
+                  <a:srgbClr val="1F472C"/>
+                </a:solidFill>
+              </a:rPr>
+              <a:t>칫솔형 치실</a:t>
+            </a:r>
+            <a:endParaRPr lang="en-US" sz="1600" dirty="0"/>
+          </a:p>
+        </p:txBody>
+      </p:sp>
+      <p:sp>
+        <p:nvSpPr>
+          <p:cNvPr id="13" name="제품 설명"/>
+          <p:cNvSpPr txBox="1"/>
+          <p:nvPr/>
+        </p:nvSpPr>
+        <p:spPr>
+          <a:xfrm>
+            <a:off x="4612538" y="4846320"/>
+            <a:ext cx="2966618" cy="685800"/>
+          </a:xfrm>
+          <a:prstGeom prst="rect">
+            <a:avLst/>
+          </a:prstGeom>
+          <a:noFill/>
+          <a:ln/>
+        </p:spPr>
+        <p:txBody>
+          <a:bodyPr wrap="square" lIns="0" tIns="0" rIns="0" bIns="0" rtlCol="0" anchor="t"/>
+          <a:lstStyle/>
+          <a:p>
+            <a:pPr indent="0" marL="0">
               <a:lnSpc>
-                <a:spcPct val="125000"/>
+                <a:spcPct val="130000"/>
               </a:lnSpc>
               <a:buNone/>
             </a:pPr>
             <a:r>
-              <a:rPr lang="en-US" sz="1600" b="1" dirty="0">
-                <a:solidFill>
-                  <a:schemeClr val="tx1"/>
-                </a:solidFill>
-              </a:rPr>
-              <a:t>02  기획 · 설계</a:t>
-            </a:r>
-            <a:endParaRPr lang="en-US" sz="1600" dirty="0"/>
+              <a:rPr lang="en-US" sz="1100" dirty="0">
+                <a:solidFill>
+                  <a:srgbClr val="4A4A40"/>
+                </a:solidFill>
+              </a:rPr>
+              <a:t>ㄱ자 헤드 · 칫솔처럼 쥐는 손잡이</a:t>
+            </a:r>
+            <a:endParaRPr lang="en-US" sz="1100" dirty="0"/>
           </a:p>
           <a:p>
             <a:pPr indent="0" marL="0">
               <a:lnSpc>
-                <a:spcPct val="125000"/>
+                <a:spcPct val="130000"/>
               </a:lnSpc>
               <a:buNone/>
             </a:pPr>
             <a:r>
-              <a:rPr lang="en-US" sz="1150" dirty="0">
-                <a:solidFill>
-                  <a:schemeClr val="tx2"/>
-                </a:solidFill>
-              </a:rPr>
-              <a:t>제품 디자인 · 금형 · 상표/특허 출원 · 라이선싱</a:t>
-            </a:r>
-            <a:endParaRPr lang="en-US" sz="1600" dirty="0"/>
-          </a:p>
-        </p:txBody>
-      </p:sp>
-      <p:sp>
-        <p:nvSpPr>
-          <p:cNvPr id="8" name="역량 카드"/>
+              <a:rPr lang="en-US" sz="1100" dirty="0">
+                <a:solidFill>
+                  <a:srgbClr val="4A4A40"/>
+                </a:solidFill>
+              </a:rPr>
+              <a:t>리필 20개입 교체형 · 세트 4,900원</a:t>
+            </a:r>
+            <a:endParaRPr lang="en-US" sz="1100" dirty="0"/>
+          </a:p>
+        </p:txBody>
+      </p:sp>
+      <p:sp>
+        <p:nvSpPr>
+          <p:cNvPr id="14" name="제품 카드"/>
           <p:cNvSpPr/>
           <p:nvPr/>
         </p:nvSpPr>
         <p:spPr>
           <a:xfrm>
-            <a:off x="8051597" y="1691640"/>
-            <a:ext cx="3545738" cy="1234440"/>
+            <a:off x="8082077" y="1965960"/>
+            <a:ext cx="3515258" cy="3657600"/>
           </a:xfrm>
           <a:prstGeom prst="roundRect">
             <a:avLst>
-              <a:gd name="adj" fmla="val 5926"/>
+              <a:gd name="adj" fmla="val 2081"/>
             </a:avLst>
           </a:prstGeom>
           <a:solidFill>
-            <a:schemeClr val="accent4"/>
+            <a:srgbClr val="FFFFFF"/>
           </a:solidFill>
           <a:ln/>
         </p:spPr>
       </p:sp>
-      <p:sp>
-        <p:nvSpPr>
-          <p:cNvPr id="9" name="역량"/>
+      <p:pic>
+        <p:nvPicPr>
+          <p:cNvPr id="15" name="물때 제로 양치컵" descr="img/cup-tilt.jpg">    </p:cNvPr>
+          <p:cNvPicPr>
+            <a:picLocks noChangeAspect="1"/>
+          </p:cNvPicPr>
+          <p:nvPr/>
+        </p:nvPicPr>
+        <p:blipFill>
+          <a:blip r:embed="rId4"/>
+          <a:srcRect l="0" r="0" t="0" b="0"/>
+          <a:stretch/>
+        </p:blipFill>
+        <p:spPr>
+          <a:xfrm>
+            <a:off x="8219237" y="2103120"/>
+            <a:ext cx="3240938" cy="2148840"/>
+          </a:xfrm>
+          <a:prstGeom prst="rect">
+            <a:avLst/>
+          </a:prstGeom>
+        </p:spPr>
+      </p:pic>
+      <p:sp>
+        <p:nvSpPr>
+          <p:cNvPr id="16" name="제품명"/>
           <p:cNvSpPr txBox="1"/>
           <p:nvPr/>
         </p:nvSpPr>
         <p:spPr>
           <a:xfrm>
-            <a:off x="8325917" y="1874520"/>
-            <a:ext cx="2997098" cy="914400"/>
+            <a:off x="8356397" y="4434840"/>
+            <a:ext cx="2966618" cy="365760"/>
           </a:xfrm>
           <a:prstGeom prst="rect">
             <a:avLst/>
@@ -2642,634 +2694,142 @@
           <a:lstStyle/>
           <a:p>
             <a:pPr indent="0" marL="0">
+              <a:buNone/>
+            </a:pPr>
+            <a:r>
+              <a:rPr lang="en-US" sz="1600" b="1" dirty="0">
+                <a:solidFill>
+                  <a:srgbClr val="1F472C"/>
+                </a:solidFill>
+              </a:rPr>
+              <a:t>물때 제로 양치컵</a:t>
+            </a:r>
+            <a:endParaRPr lang="en-US" sz="1600" dirty="0"/>
+          </a:p>
+        </p:txBody>
+      </p:sp>
+      <p:sp>
+        <p:nvSpPr>
+          <p:cNvPr id="17" name="제품 설명"/>
+          <p:cNvSpPr txBox="1"/>
+          <p:nvPr/>
+        </p:nvSpPr>
+        <p:spPr>
+          <a:xfrm>
+            <a:off x="8356397" y="4846320"/>
+            <a:ext cx="2966618" cy="685800"/>
+          </a:xfrm>
+          <a:prstGeom prst="rect">
+            <a:avLst/>
+          </a:prstGeom>
+          <a:noFill/>
+          <a:ln/>
+        </p:spPr>
+        <p:txBody>
+          <a:bodyPr wrap="square" lIns="0" tIns="0" rIns="0" bIns="0" rtlCol="0" anchor="t"/>
+          <a:lstStyle/>
+          <a:p>
+            <a:pPr indent="0" marL="0">
               <a:lnSpc>
-                <a:spcPct val="125000"/>
+                <a:spcPct val="130000"/>
               </a:lnSpc>
               <a:buNone/>
             </a:pPr>
             <a:r>
-              <a:rPr lang="en-US" sz="1600" b="1" dirty="0">
-                <a:solidFill>
-                  <a:schemeClr val="tx1"/>
-                </a:solidFill>
-              </a:rPr>
-              <a:t>03  생산 · 납품</a:t>
-            </a:r>
-            <a:endParaRPr lang="en-US" sz="1600" dirty="0"/>
+              <a:rPr lang="en-US" sz="1100" dirty="0">
+                <a:solidFill>
+                  <a:srgbClr val="4A4A40"/>
+                </a:solidFill>
+              </a:rPr>
+              <a:t>40° 셀프 드레인 설계 — 기울여 세워 말림</a:t>
+            </a:r>
+            <a:endParaRPr lang="en-US" sz="1100" dirty="0"/>
           </a:p>
           <a:p>
             <a:pPr indent="0" marL="0">
               <a:lnSpc>
-                <a:spcPct val="125000"/>
+                <a:spcPct val="130000"/>
               </a:lnSpc>
               <a:buNone/>
             </a:pPr>
             <a:r>
-              <a:rPr lang="en-US" sz="1150" dirty="0">
-                <a:solidFill>
-                  <a:schemeClr val="tx2"/>
-                </a:solidFill>
-              </a:rPr>
-              <a:t>국내 제조 · 대형 매장 전국 납품 · B2B/OEM</a:t>
-            </a:r>
-            <a:endParaRPr lang="en-US" sz="1600" dirty="0"/>
-          </a:p>
-        </p:txBody>
-      </p:sp>
-      <p:sp>
-        <p:nvSpPr>
-          <p:cNvPr id="10" name="Text 8"/>
-          <p:cNvSpPr txBox="1"/>
-          <p:nvPr/>
-        </p:nvSpPr>
-        <p:spPr>
-          <a:xfrm>
-            <a:off x="594360" y="3246120"/>
-            <a:ext cx="2743200" cy="256032"/>
-          </a:xfrm>
-          <a:prstGeom prst="rect">
-            <a:avLst/>
-          </a:prstGeom>
-          <a:noFill/>
-          <a:ln/>
-        </p:spPr>
-        <p:txBody>
-          <a:bodyPr wrap="square" lIns="0" tIns="0" rIns="0" bIns="0" rtlCol="0" anchor="t"/>
-          <a:lstStyle/>
-          <a:p>
-            <a:pPr indent="0" marL="0">
-              <a:buNone/>
-            </a:pPr>
-            <a:r>
-              <a:rPr lang="en-US" sz="1000" b="1" spc="400" kern="0" dirty="0">
-                <a:solidFill>
-                  <a:schemeClr val="accent3"/>
-                </a:solidFill>
-              </a:rPr>
-              <a:t>HISTORY</a:t>
-            </a:r>
-            <a:endParaRPr lang="en-US" sz="1000" dirty="0"/>
-          </a:p>
-        </p:txBody>
-      </p:sp>
-      <p:sp>
-        <p:nvSpPr>
-          <p:cNvPr id="11" name="타임라인"/>
+              <a:rPr lang="en-US" sz="1100" dirty="0">
+                <a:solidFill>
+                  <a:srgbClr val="4A4A40"/>
+                </a:solidFill>
+              </a:rPr>
+              <a:t>CXP 소재 · 110g · 국내 제조</a:t>
+            </a:r>
+            <a:endParaRPr lang="en-US" sz="1100" dirty="0"/>
+          </a:p>
+        </p:txBody>
+      </p:sp>
+      <p:sp>
+        <p:nvSpPr>
+          <p:cNvPr id="18" name="CXP 띠"/>
           <p:cNvSpPr/>
           <p:nvPr/>
         </p:nvSpPr>
         <p:spPr>
           <a:xfrm>
-            <a:off x="594360" y="3767328"/>
-            <a:ext cx="11002975" cy="0"/>
-          </a:xfrm>
-          <a:prstGeom prst="line">
-            <a:avLst/>
-          </a:prstGeom>
-          <a:noFill/>
-          <a:ln w="25400">
-            <a:solidFill>
-              <a:srgbClr val="D8D6EE"/>
-            </a:solidFill>
-            <a:prstDash val="solid"/>
-          </a:ln>
-        </p:spPr>
-      </p:sp>
-      <p:sp>
-        <p:nvSpPr>
-          <p:cNvPr id="12" name="연혁 점"/>
-          <p:cNvSpPr/>
-          <p:nvPr/>
-        </p:nvSpPr>
-        <p:spPr>
-          <a:xfrm>
-            <a:off x="594360" y="3630168"/>
-            <a:ext cx="274320" cy="274320"/>
-          </a:xfrm>
-          <a:prstGeom prst="ellipse">
-            <a:avLst/>
-          </a:prstGeom>
-          <a:solidFill>
-            <a:schemeClr val="accent3"/>
-          </a:solidFill>
-          <a:ln/>
-        </p:spPr>
-      </p:sp>
-      <p:sp>
-        <p:nvSpPr>
-          <p:cNvPr id="13" name="Text 11"/>
-          <p:cNvSpPr txBox="1"/>
-          <p:nvPr/>
-        </p:nvSpPr>
-        <p:spPr>
-          <a:xfrm>
-            <a:off x="594360" y="4069080"/>
-            <a:ext cx="2613584" cy="457200"/>
-          </a:xfrm>
-          <a:prstGeom prst="rect">
-            <a:avLst/>
-          </a:prstGeom>
-          <a:noFill/>
-          <a:ln/>
-        </p:spPr>
-        <p:txBody>
-          <a:bodyPr wrap="square" lIns="0" tIns="0" rIns="0" bIns="0" rtlCol="0" anchor="t"/>
-          <a:lstStyle/>
-          <a:p>
-            <a:pPr indent="0" marL="0">
-              <a:buNone/>
-            </a:pPr>
-            <a:r>
-              <a:rPr lang="en-US" sz="2400" b="1" dirty="0">
-                <a:solidFill>
-                  <a:schemeClr val="tx1"/>
-                </a:solidFill>
-              </a:rPr>
-              <a:t>2023</a:t>
-            </a:r>
-            <a:endParaRPr lang="en-US" sz="2400" dirty="0"/>
-          </a:p>
-        </p:txBody>
-      </p:sp>
-      <p:sp>
-        <p:nvSpPr>
-          <p:cNvPr id="14" name="연혁 2023"/>
-          <p:cNvSpPr txBox="1"/>
-          <p:nvPr/>
-        </p:nvSpPr>
-        <p:spPr>
-          <a:xfrm>
-            <a:off x="594360" y="4681728"/>
-            <a:ext cx="2522144" cy="1280160"/>
-          </a:xfrm>
-          <a:prstGeom prst="rect">
-            <a:avLst/>
-          </a:prstGeom>
-          <a:noFill/>
-          <a:ln/>
-        </p:spPr>
-        <p:txBody>
-          <a:bodyPr wrap="square" lIns="0" tIns="0" rIns="0" bIns="0" rtlCol="0" anchor="t"/>
-          <a:lstStyle/>
-          <a:p>
-            <a:pPr indent="0" marL="0">
-              <a:lnSpc>
-                <a:spcPct val="135000"/>
-              </a:lnSpc>
-              <a:buNone/>
-            </a:pPr>
-            <a:r>
-              <a:rPr lang="en-US" sz="1150" dirty="0">
-                <a:solidFill>
-                  <a:schemeClr val="tx2"/>
-                </a:solidFill>
-              </a:rPr>
-              <a:t>창업진흥원 국가과제</a:t>
-            </a:r>
-            <a:endParaRPr lang="en-US" sz="1150" dirty="0"/>
-          </a:p>
-          <a:p>
-            <a:pPr indent="0" marL="0">
-              <a:lnSpc>
-                <a:spcPct val="135000"/>
-              </a:lnSpc>
-              <a:buNone/>
-            </a:pPr>
-            <a:r>
-              <a:rPr lang="en-US" sz="1150" dirty="0">
-                <a:solidFill>
-                  <a:schemeClr val="tx2"/>
-                </a:solidFill>
-              </a:rPr>
-              <a:t>㈜알앤디메이커스 창립</a:t>
-            </a:r>
-            <a:endParaRPr lang="en-US" sz="1150" dirty="0"/>
-          </a:p>
-          <a:p>
-            <a:pPr indent="0" marL="0">
-              <a:lnSpc>
-                <a:spcPct val="135000"/>
-              </a:lnSpc>
-              <a:buNone/>
-            </a:pPr>
-            <a:r>
-              <a:rPr lang="en-US" sz="1150" dirty="0">
-                <a:solidFill>
-                  <a:schemeClr val="tx2"/>
-                </a:solidFill>
-              </a:rPr>
-              <a:t>다이소 전국 매장 입점</a:t>
-            </a:r>
-            <a:endParaRPr lang="en-US" sz="1150" dirty="0"/>
-          </a:p>
-        </p:txBody>
-      </p:sp>
-      <p:sp>
-        <p:nvSpPr>
-          <p:cNvPr id="15" name="연혁 점"/>
-          <p:cNvSpPr/>
-          <p:nvPr/>
-        </p:nvSpPr>
-        <p:spPr>
-          <a:xfrm>
-            <a:off x="3390824" y="3630168"/>
-            <a:ext cx="274320" cy="274320"/>
-          </a:xfrm>
-          <a:prstGeom prst="ellipse">
-            <a:avLst/>
-          </a:prstGeom>
-          <a:solidFill>
-            <a:schemeClr val="accent3"/>
-          </a:solidFill>
-          <a:ln/>
-        </p:spPr>
-      </p:sp>
-      <p:sp>
-        <p:nvSpPr>
-          <p:cNvPr id="16" name="Text 14"/>
-          <p:cNvSpPr txBox="1"/>
-          <p:nvPr/>
-        </p:nvSpPr>
-        <p:spPr>
-          <a:xfrm>
-            <a:off x="3390824" y="4069080"/>
-            <a:ext cx="2613584" cy="457200"/>
-          </a:xfrm>
-          <a:prstGeom prst="rect">
-            <a:avLst/>
-          </a:prstGeom>
-          <a:noFill/>
-          <a:ln/>
-        </p:spPr>
-        <p:txBody>
-          <a:bodyPr wrap="square" lIns="0" tIns="0" rIns="0" bIns="0" rtlCol="0" anchor="t"/>
-          <a:lstStyle/>
-          <a:p>
-            <a:pPr indent="0" marL="0">
-              <a:buNone/>
-            </a:pPr>
-            <a:r>
-              <a:rPr lang="en-US" sz="2400" b="1" dirty="0">
-                <a:solidFill>
-                  <a:schemeClr val="tx1"/>
-                </a:solidFill>
-              </a:rPr>
-              <a:t>2024</a:t>
-            </a:r>
-            <a:endParaRPr lang="en-US" sz="2400" dirty="0"/>
-          </a:p>
-        </p:txBody>
-      </p:sp>
-      <p:sp>
-        <p:nvSpPr>
-          <p:cNvPr id="17" name="연혁 2024"/>
-          <p:cNvSpPr txBox="1"/>
-          <p:nvPr/>
-        </p:nvSpPr>
-        <p:spPr>
-          <a:xfrm>
-            <a:off x="3390824" y="4681728"/>
-            <a:ext cx="2522144" cy="1280160"/>
-          </a:xfrm>
-          <a:prstGeom prst="rect">
-            <a:avLst/>
-          </a:prstGeom>
-          <a:noFill/>
-          <a:ln/>
-        </p:spPr>
-        <p:txBody>
-          <a:bodyPr wrap="square" lIns="0" tIns="0" rIns="0" bIns="0" rtlCol="0" anchor="t"/>
-          <a:lstStyle/>
-          <a:p>
-            <a:pPr indent="0" marL="0">
-              <a:lnSpc>
-                <a:spcPct val="135000"/>
-              </a:lnSpc>
-              <a:buNone/>
-            </a:pPr>
-            <a:r>
-              <a:rPr lang="en-US" sz="1150" dirty="0">
-                <a:solidFill>
-                  <a:schemeClr val="tx2"/>
-                </a:solidFill>
-              </a:rPr>
-              <a:t>환경부 새활용지원사업</a:t>
-            </a:r>
-            <a:endParaRPr lang="en-US" sz="1150" dirty="0"/>
-          </a:p>
-          <a:p>
-            <a:pPr indent="0" marL="0">
-              <a:lnSpc>
-                <a:spcPct val="135000"/>
-              </a:lnSpc>
-              <a:buNone/>
-            </a:pPr>
-            <a:r>
-              <a:rPr lang="en-US" sz="1150" dirty="0">
-                <a:solidFill>
-                  <a:schemeClr val="tx2"/>
-                </a:solidFill>
-              </a:rPr>
-              <a:t>오피스디포·오피스웨이 납품</a:t>
-            </a:r>
-            <a:endParaRPr lang="en-US" sz="1150" dirty="0"/>
-          </a:p>
-          <a:p>
-            <a:pPr indent="0" marL="0">
-              <a:lnSpc>
-                <a:spcPct val="135000"/>
-              </a:lnSpc>
-              <a:buNone/>
-            </a:pPr>
-            <a:r>
-              <a:rPr lang="en-US" sz="1150" dirty="0">
-                <a:solidFill>
-                  <a:schemeClr val="tx2"/>
-                </a:solidFill>
-              </a:rPr>
-              <a:t>중국 첫 수출</a:t>
-            </a:r>
-            <a:endParaRPr lang="en-US" sz="1150" dirty="0"/>
-          </a:p>
-        </p:txBody>
-      </p:sp>
-      <p:sp>
-        <p:nvSpPr>
-          <p:cNvPr id="18" name="연혁 점"/>
-          <p:cNvSpPr/>
-          <p:nvPr/>
-        </p:nvSpPr>
-        <p:spPr>
-          <a:xfrm>
-            <a:off x="6187288" y="3630168"/>
-            <a:ext cx="274320" cy="274320"/>
-          </a:xfrm>
-          <a:prstGeom prst="ellipse">
-            <a:avLst/>
-          </a:prstGeom>
-          <a:solidFill>
-            <a:schemeClr val="accent3"/>
-          </a:solidFill>
-          <a:ln/>
-        </p:spPr>
-      </p:sp>
-      <p:sp>
-        <p:nvSpPr>
-          <p:cNvPr id="19" name="Text 17"/>
-          <p:cNvSpPr txBox="1"/>
-          <p:nvPr/>
-        </p:nvSpPr>
-        <p:spPr>
-          <a:xfrm>
-            <a:off x="6187288" y="4069080"/>
-            <a:ext cx="2613584" cy="457200"/>
-          </a:xfrm>
-          <a:prstGeom prst="rect">
-            <a:avLst/>
-          </a:prstGeom>
-          <a:noFill/>
-          <a:ln/>
-        </p:spPr>
-        <p:txBody>
-          <a:bodyPr wrap="square" lIns="0" tIns="0" rIns="0" bIns="0" rtlCol="0" anchor="t"/>
-          <a:lstStyle/>
-          <a:p>
-            <a:pPr indent="0" marL="0">
-              <a:buNone/>
-            </a:pPr>
-            <a:r>
-              <a:rPr lang="en-US" sz="2400" b="1" dirty="0">
-                <a:solidFill>
-                  <a:schemeClr val="tx1"/>
-                </a:solidFill>
-              </a:rPr>
-              <a:t>2025</a:t>
-            </a:r>
-            <a:endParaRPr lang="en-US" sz="2400" dirty="0"/>
-          </a:p>
-        </p:txBody>
-      </p:sp>
-      <p:sp>
-        <p:nvSpPr>
-          <p:cNvPr id="20" name="연혁 2025"/>
-          <p:cNvSpPr txBox="1"/>
-          <p:nvPr/>
-        </p:nvSpPr>
-        <p:spPr>
-          <a:xfrm>
-            <a:off x="6187288" y="4681728"/>
-            <a:ext cx="2522144" cy="1280160"/>
-          </a:xfrm>
-          <a:prstGeom prst="rect">
-            <a:avLst/>
-          </a:prstGeom>
-          <a:noFill/>
-          <a:ln/>
-        </p:spPr>
-        <p:txBody>
-          <a:bodyPr wrap="square" lIns="0" tIns="0" rIns="0" bIns="0" rtlCol="0" anchor="t"/>
-          <a:lstStyle/>
-          <a:p>
-            <a:pPr indent="0" marL="0">
-              <a:lnSpc>
-                <a:spcPct val="135000"/>
-              </a:lnSpc>
-              <a:buNone/>
-            </a:pPr>
-            <a:r>
-              <a:rPr lang="en-US" sz="1150" dirty="0">
-                <a:solidFill>
-                  <a:schemeClr val="tx2"/>
-                </a:solidFill>
-              </a:rPr>
-              <a:t>상표권·BM 특허 출원</a:t>
-            </a:r>
-            <a:endParaRPr lang="en-US" sz="1150" dirty="0"/>
-          </a:p>
-          <a:p>
-            <a:pPr indent="0" marL="0">
-              <a:lnSpc>
-                <a:spcPct val="135000"/>
-              </a:lnSpc>
-              <a:buNone/>
-            </a:pPr>
-            <a:r>
-              <a:rPr lang="en-US" sz="1150" dirty="0">
-                <a:solidFill>
-                  <a:schemeClr val="tx2"/>
-                </a:solidFill>
-              </a:rPr>
-              <a:t>꿈돌이 캐릭터 라이선싱</a:t>
-            </a:r>
-            <a:endParaRPr lang="en-US" sz="1150" dirty="0"/>
-          </a:p>
-          <a:p>
-            <a:pPr indent="0" marL="0">
-              <a:lnSpc>
-                <a:spcPct val="135000"/>
-              </a:lnSpc>
-              <a:buNone/>
-            </a:pPr>
-            <a:r>
-              <a:rPr lang="en-US" sz="1150" dirty="0">
-                <a:solidFill>
-                  <a:schemeClr val="tx2"/>
-                </a:solidFill>
-              </a:rPr>
-              <a:t>롯데패키징앤솔루션·서브원 납품</a:t>
-            </a:r>
-            <a:endParaRPr lang="en-US" sz="1150" dirty="0"/>
-          </a:p>
-        </p:txBody>
-      </p:sp>
-      <p:sp>
-        <p:nvSpPr>
-          <p:cNvPr id="21" name="연혁 점"/>
-          <p:cNvSpPr/>
-          <p:nvPr/>
-        </p:nvSpPr>
-        <p:spPr>
-          <a:xfrm>
-            <a:off x="8983751" y="3630168"/>
-            <a:ext cx="274320" cy="274320"/>
-          </a:xfrm>
-          <a:prstGeom prst="ellipse">
-            <a:avLst/>
-          </a:prstGeom>
-          <a:solidFill>
-            <a:srgbClr val="C6F432"/>
-          </a:solidFill>
-          <a:ln/>
-        </p:spPr>
-      </p:sp>
-      <p:sp>
-        <p:nvSpPr>
-          <p:cNvPr id="22" name="Text 20"/>
-          <p:cNvSpPr txBox="1"/>
-          <p:nvPr/>
-        </p:nvSpPr>
-        <p:spPr>
-          <a:xfrm>
-            <a:off x="8983751" y="4069080"/>
-            <a:ext cx="2613584" cy="457200"/>
-          </a:xfrm>
-          <a:prstGeom prst="rect">
-            <a:avLst/>
-          </a:prstGeom>
-          <a:noFill/>
-          <a:ln/>
-        </p:spPr>
-        <p:txBody>
-          <a:bodyPr wrap="square" lIns="0" tIns="0" rIns="0" bIns="0" rtlCol="0" anchor="t"/>
-          <a:lstStyle/>
-          <a:p>
-            <a:pPr indent="0" marL="0">
-              <a:buNone/>
-            </a:pPr>
-            <a:r>
-              <a:rPr lang="en-US" sz="2400" b="1" dirty="0">
-                <a:solidFill>
-                  <a:schemeClr val="tx1"/>
-                </a:solidFill>
-              </a:rPr>
-              <a:t>2026</a:t>
-            </a:r>
-            <a:endParaRPr lang="en-US" sz="2400" dirty="0"/>
-          </a:p>
-        </p:txBody>
-      </p:sp>
-      <p:sp>
-        <p:nvSpPr>
-          <p:cNvPr id="23" name="2026 강조"/>
-          <p:cNvSpPr/>
-          <p:nvPr/>
-        </p:nvSpPr>
-        <p:spPr>
-          <a:xfrm>
-            <a:off x="8874023" y="4572000"/>
-            <a:ext cx="2723312" cy="1417320"/>
+            <a:off x="594360" y="5806440"/>
+            <a:ext cx="11002975" cy="411480"/>
           </a:xfrm>
           <a:prstGeom prst="roundRect">
             <a:avLst>
-              <a:gd name="adj" fmla="val 3871"/>
+              <a:gd name="adj" fmla="val 13333"/>
             </a:avLst>
           </a:prstGeom>
           <a:solidFill>
-            <a:srgbClr val="F4FBD9"/>
+            <a:srgbClr val="1F472C"/>
           </a:solidFill>
           <a:ln/>
         </p:spPr>
       </p:sp>
       <p:sp>
         <p:nvSpPr>
-          <p:cNvPr id="24" name="연혁 2026"/>
+          <p:cNvPr id="19" name="CXP 설명"/>
           <p:cNvSpPr txBox="1"/>
           <p:nvPr/>
         </p:nvSpPr>
         <p:spPr>
           <a:xfrm>
-            <a:off x="8983751" y="4681728"/>
-            <a:ext cx="2522144" cy="1280160"/>
-          </a:xfrm>
-          <a:prstGeom prst="rect">
-            <a:avLst/>
-          </a:prstGeom>
-          <a:noFill/>
-          <a:ln/>
-        </p:spPr>
-        <p:txBody>
-          <a:bodyPr wrap="square" lIns="0" tIns="0" rIns="0" bIns="0" rtlCol="0" anchor="t"/>
-          <a:lstStyle/>
-          <a:p>
-            <a:pPr indent="0" marL="0">
-              <a:lnSpc>
-                <a:spcPct val="135000"/>
-              </a:lnSpc>
-              <a:buNone/>
-            </a:pPr>
-            <a:r>
-              <a:rPr lang="en-US" sz="1150" b="1" dirty="0">
-                <a:solidFill>
-                  <a:schemeClr val="tx1"/>
-                </a:solidFill>
-              </a:rPr>
-              <a:t>환경부 새활용지원사업 2차</a:t>
-            </a:r>
-            <a:endParaRPr lang="en-US" sz="1150" dirty="0"/>
-          </a:p>
-          <a:p>
-            <a:pPr indent="0" marL="0">
-              <a:lnSpc>
-                <a:spcPct val="135000"/>
-              </a:lnSpc>
-              <a:buNone/>
-            </a:pPr>
-            <a:r>
-              <a:rPr lang="en-US" sz="1150" b="1" dirty="0">
-                <a:solidFill>
-                  <a:schemeClr val="tx1"/>
-                </a:solidFill>
-              </a:rPr>
-              <a:t>라라슈(RhaRa Shoe) 런칭</a:t>
-            </a:r>
-            <a:endParaRPr lang="en-US" sz="1150" dirty="0"/>
-          </a:p>
-          <a:p>
-            <a:pPr indent="0" marL="0">
-              <a:lnSpc>
-                <a:spcPct val="135000"/>
-              </a:lnSpc>
-              <a:buNone/>
-            </a:pPr>
-            <a:r>
-              <a:rPr lang="en-US" sz="1150" b="1" dirty="0">
-                <a:solidFill>
-                  <a:schemeClr val="tx1"/>
-                </a:solidFill>
-              </a:rPr>
-              <a:t>11.11 첫 라인업 오픈</a:t>
-            </a:r>
-            <a:endParaRPr lang="en-US" sz="1150" dirty="0"/>
+            <a:off x="868680" y="5806440"/>
+            <a:ext cx="10454335" cy="411480"/>
+          </a:xfrm>
+          <a:prstGeom prst="rect">
+            <a:avLst/>
+          </a:prstGeom>
+          <a:noFill/>
+          <a:ln/>
+        </p:spPr>
+        <p:txBody>
+          <a:bodyPr wrap="square" lIns="0" tIns="0" rIns="0" bIns="0" rtlCol="0" anchor="ctr"/>
+          <a:lstStyle/>
+          <a:p>
+            <a:pPr indent="0" marL="0">
+              <a:buNone/>
+            </a:pPr>
+            <a:r>
+              <a:rPr lang="en-US" sz="1100" b="1" dirty="0">
+                <a:solidFill>
+                  <a:srgbClr val="FBD827"/>
+                </a:solidFill>
+              </a:rPr>
+              <a:t>CXP   </a:t>
+            </a:r>
+            <a:pPr indent="0" marL="0">
+              <a:buNone/>
+            </a:pPr>
+            <a:r>
+              <a:rPr lang="en-US" sz="1100" dirty="0">
+                <a:solidFill>
+                  <a:srgbClr val="F2EDE1"/>
+                </a:solidFill>
+              </a:rPr>
+              <a:t>간벌재 등 임업부산물을 활용한 셀룰로스 기반 복합소재  ·  칫솔·치실·양치컵 공통 소재</a:t>
+            </a:r>
+            <a:endParaRPr lang="en-US" sz="1100" dirty="0"/>
           </a:p>
         </p:txBody>
       </p:sp>
@@ -3303,7 +2863,7 @@
             <a:lvl1pPr>
               <a:defRPr sz="800">
                 <a:solidFill>
-                  <a:schemeClr val="tx2"/>
+                  <a:srgbClr val="6B6B5E"/>
                 </a:solidFill>
               </a:defRPr>
             </a:lvl1pPr>
@@ -3930,7 +3490,7 @@
                   <a:srgbClr val="E0E828"/>
                 </a:solidFill>
               </a:rPr>
-              <a:t>LAUNCH &amp; PARTNERSHIP</a:t>
+              <a:t>COMPANY  ·  OEM / ODM</a:t>
             </a:r>
             <a:endParaRPr lang="en-US" sz="1000" dirty="0"/>
           </a:p>
@@ -3968,7 +3528,7 @@
                   <a:schemeClr val="bg1"/>
                 </a:solidFill>
               </a:rPr>
-              <a:t>11월, 현장에서 만나요</a:t>
+              <a:t>소재부터 납품까지, 한 회사에서</a:t>
             </a:r>
             <a:endParaRPr lang="en-US" sz="3000" dirty="0"/>
           </a:p>
@@ -3976,276 +3536,861 @@
       </p:sp>
       <p:sp>
         <p:nvSpPr>
-          <p:cNvPr id="4" name="Text 2"/>
-          <p:cNvSpPr txBox="1"/>
-          <p:nvPr/>
-        </p:nvSpPr>
-        <p:spPr>
-          <a:xfrm>
-            <a:off x="594360" y="1783080"/>
-            <a:ext cx="2011680" cy="457200"/>
-          </a:xfrm>
-          <a:prstGeom prst="rect">
-            <a:avLst/>
-          </a:prstGeom>
-          <a:noFill/>
-          <a:ln/>
-        </p:spPr>
-        <p:txBody>
-          <a:bodyPr wrap="square" lIns="0" tIns="0" rIns="0" bIns="0" rtlCol="0" anchor="t"/>
-          <a:lstStyle/>
-          <a:p>
-            <a:pPr indent="0" marL="0">
-              <a:buNone/>
-            </a:pPr>
-            <a:r>
-              <a:rPr lang="en-US" sz="2200" b="1" dirty="0">
-                <a:solidFill>
-                  <a:srgbClr val="E0E828"/>
-                </a:solidFill>
-              </a:rPr>
-              <a:t>11.11</a:t>
-            </a:r>
-            <a:endParaRPr lang="en-US" sz="2200" dirty="0"/>
-          </a:p>
-        </p:txBody>
-      </p:sp>
-      <p:sp>
-        <p:nvSpPr>
-          <p:cNvPr id="5" name="Text 3"/>
-          <p:cNvSpPr txBox="1"/>
-          <p:nvPr/>
-        </p:nvSpPr>
-        <p:spPr>
-          <a:xfrm>
-            <a:off x="2743200" y="1801368"/>
-            <a:ext cx="3931920" cy="731520"/>
-          </a:xfrm>
-          <a:prstGeom prst="rect">
-            <a:avLst/>
-          </a:prstGeom>
-          <a:noFill/>
-          <a:ln/>
-        </p:spPr>
-        <p:txBody>
-          <a:bodyPr wrap="square" lIns="0" tIns="0" rIns="0" bIns="0" rtlCol="0" anchor="t"/>
-          <a:lstStyle/>
-          <a:p>
-            <a:pPr indent="0" marL="0">
-              <a:buNone/>
-            </a:pPr>
-            <a:r>
-              <a:rPr lang="en-US" sz="1500" b="1" dirty="0">
-                <a:solidFill>
-                  <a:schemeClr val="bg1"/>
-                </a:solidFill>
-              </a:rPr>
-              <a:t>라라슈 1차 라인업 오픈</a:t>
-            </a:r>
-            <a:endParaRPr lang="en-US" sz="1500" dirty="0"/>
-          </a:p>
-          <a:p>
-            <a:pPr indent="0" marL="0">
-              <a:buNone/>
-            </a:pPr>
-            <a:r>
-              <a:rPr lang="en-US" sz="1150" dirty="0">
-                <a:solidFill>
-                  <a:schemeClr val="bg2"/>
-                </a:solidFill>
-              </a:rPr>
-              <a:t>워킹화 · 인솔 온라인 출시</a:t>
-            </a:r>
-            <a:endParaRPr lang="en-US" sz="1500" dirty="0"/>
-          </a:p>
-        </p:txBody>
-      </p:sp>
-      <p:sp>
-        <p:nvSpPr>
-          <p:cNvPr id="6" name="Text 4"/>
-          <p:cNvSpPr txBox="1"/>
-          <p:nvPr/>
-        </p:nvSpPr>
-        <p:spPr>
-          <a:xfrm>
-            <a:off x="594360" y="2770632"/>
-            <a:ext cx="2011680" cy="457200"/>
-          </a:xfrm>
-          <a:prstGeom prst="rect">
-            <a:avLst/>
-          </a:prstGeom>
-          <a:noFill/>
-          <a:ln/>
-        </p:spPr>
-        <p:txBody>
-          <a:bodyPr wrap="square" lIns="0" tIns="0" rIns="0" bIns="0" rtlCol="0" anchor="t"/>
-          <a:lstStyle/>
-          <a:p>
-            <a:pPr indent="0" marL="0">
-              <a:buNone/>
-            </a:pPr>
-            <a:r>
-              <a:rPr lang="en-US" sz="2200" b="1" dirty="0">
-                <a:solidFill>
-                  <a:srgbClr val="E0E828"/>
-                </a:solidFill>
-              </a:rPr>
-              <a:t>11.12 – 15</a:t>
-            </a:r>
-            <a:endParaRPr lang="en-US" sz="2200" dirty="0"/>
-          </a:p>
-        </p:txBody>
-      </p:sp>
-      <p:sp>
-        <p:nvSpPr>
-          <p:cNvPr id="7" name="Text 5"/>
-          <p:cNvSpPr txBox="1"/>
-          <p:nvPr/>
-        </p:nvSpPr>
-        <p:spPr>
-          <a:xfrm>
-            <a:off x="2743200" y="2788920"/>
-            <a:ext cx="3931920" cy="731520"/>
-          </a:xfrm>
-          <a:prstGeom prst="rect">
-            <a:avLst/>
-          </a:prstGeom>
-          <a:noFill/>
-          <a:ln/>
-        </p:spPr>
-        <p:txBody>
-          <a:bodyPr wrap="square" lIns="0" tIns="0" rIns="0" bIns="0" rtlCol="0" anchor="t"/>
-          <a:lstStyle/>
-          <a:p>
-            <a:pPr indent="0" marL="0">
-              <a:buNone/>
-            </a:pPr>
-            <a:r>
-              <a:rPr lang="en-US" sz="1500" b="1" dirty="0">
-                <a:solidFill>
-                  <a:schemeClr val="bg1"/>
-                </a:solidFill>
-              </a:rPr>
-              <a:t>킨텍스 메가쇼</a:t>
-            </a:r>
-            <a:endParaRPr lang="en-US" sz="1500" dirty="0"/>
-          </a:p>
-          <a:p>
-            <a:pPr indent="0" marL="0">
-              <a:buNone/>
-            </a:pPr>
-            <a:r>
-              <a:rPr lang="en-US" sz="1150" dirty="0">
-                <a:solidFill>
-                  <a:schemeClr val="bg2"/>
-                </a:solidFill>
-              </a:rPr>
-              <a:t>실물 체험 · 단체 구매 상담</a:t>
-            </a:r>
-            <a:endParaRPr lang="en-US" sz="1500" dirty="0"/>
-          </a:p>
-        </p:txBody>
-      </p:sp>
-      <p:sp>
-        <p:nvSpPr>
-          <p:cNvPr id="8" name="Text 6"/>
-          <p:cNvSpPr txBox="1"/>
-          <p:nvPr/>
-        </p:nvSpPr>
-        <p:spPr>
-          <a:xfrm>
-            <a:off x="594360" y="3758184"/>
-            <a:ext cx="2011680" cy="457200"/>
-          </a:xfrm>
-          <a:prstGeom prst="rect">
-            <a:avLst/>
-          </a:prstGeom>
-          <a:noFill/>
-          <a:ln/>
-        </p:spPr>
-        <p:txBody>
-          <a:bodyPr wrap="square" lIns="0" tIns="0" rIns="0" bIns="0" rtlCol="0" anchor="t"/>
-          <a:lstStyle/>
-          <a:p>
-            <a:pPr indent="0" marL="0">
-              <a:buNone/>
-            </a:pPr>
-            <a:r>
-              <a:rPr lang="en-US" sz="2200" b="1" dirty="0">
-                <a:solidFill>
-                  <a:srgbClr val="E0E828"/>
-                </a:solidFill>
-              </a:rPr>
-              <a:t>11.26 – 29</a:t>
-            </a:r>
-            <a:endParaRPr lang="en-US" sz="2200" dirty="0"/>
-          </a:p>
-        </p:txBody>
-      </p:sp>
-      <p:sp>
-        <p:nvSpPr>
-          <p:cNvPr id="9" name="Text 7"/>
-          <p:cNvSpPr txBox="1"/>
-          <p:nvPr/>
-        </p:nvSpPr>
-        <p:spPr>
-          <a:xfrm>
-            <a:off x="2743200" y="3776472"/>
-            <a:ext cx="3931920" cy="731520"/>
-          </a:xfrm>
-          <a:prstGeom prst="rect">
-            <a:avLst/>
-          </a:prstGeom>
-          <a:noFill/>
-          <a:ln/>
-        </p:spPr>
-        <p:txBody>
-          <a:bodyPr wrap="square" lIns="0" tIns="0" rIns="0" bIns="0" rtlCol="0" anchor="t"/>
-          <a:lstStyle/>
-          <a:p>
-            <a:pPr indent="0" marL="0">
-              <a:buNone/>
-            </a:pPr>
-            <a:r>
-              <a:rPr lang="en-US" sz="1500" b="1" dirty="0">
-                <a:solidFill>
-                  <a:schemeClr val="bg1"/>
-                </a:solidFill>
-              </a:rPr>
-              <a:t>서울디자인페어 (코엑스)</a:t>
-            </a:r>
-            <a:endParaRPr lang="en-US" sz="1500" dirty="0"/>
-          </a:p>
-          <a:p>
-            <a:pPr indent="0" marL="0">
-              <a:buNone/>
-            </a:pPr>
-            <a:r>
-              <a:rPr lang="en-US" sz="1150" dirty="0">
-                <a:solidFill>
-                  <a:schemeClr val="bg2"/>
-                </a:solidFill>
-              </a:rPr>
-              <a:t>브랜드 · 소재 전시</a:t>
-            </a:r>
-            <a:endParaRPr lang="en-US" sz="1500" dirty="0"/>
-          </a:p>
-        </p:txBody>
-      </p:sp>
-      <p:sp>
-        <p:nvSpPr>
-          <p:cNvPr id="10" name="상담 박스"/>
+          <p:cNvPr id="4" name="역량 카드"/>
           <p:cNvSpPr/>
           <p:nvPr/>
         </p:nvSpPr>
         <p:spPr>
           <a:xfrm>
-            <a:off x="6675120" y="1783080"/>
-            <a:ext cx="4919472" cy="3429000"/>
+            <a:off x="594360" y="1645920"/>
+            <a:ext cx="3545738" cy="1097280"/>
           </a:xfrm>
           <a:prstGeom prst="roundRect">
             <a:avLst>
-              <a:gd name="adj" fmla="val 2667"/>
+              <a:gd name="adj" fmla="val 6667"/>
+            </a:avLst>
+          </a:prstGeom>
+          <a:solidFill>
+            <a:schemeClr val="accent5"/>
+          </a:solidFill>
+          <a:ln/>
+        </p:spPr>
+      </p:sp>
+      <p:sp>
+        <p:nvSpPr>
+          <p:cNvPr id="5" name="역량"/>
+          <p:cNvSpPr txBox="1"/>
+          <p:nvPr/>
+        </p:nvSpPr>
+        <p:spPr>
+          <a:xfrm>
+            <a:off x="868680" y="1810512"/>
+            <a:ext cx="2997098" cy="822960"/>
+          </a:xfrm>
+          <a:prstGeom prst="rect">
+            <a:avLst/>
+          </a:prstGeom>
+          <a:noFill/>
+          <a:ln/>
+        </p:spPr>
+        <p:txBody>
+          <a:bodyPr wrap="square" lIns="0" tIns="0" rIns="0" bIns="0" rtlCol="0" anchor="t"/>
+          <a:lstStyle/>
+          <a:p>
+            <a:pPr indent="0" marL="0">
+              <a:lnSpc>
+                <a:spcPct val="125000"/>
+              </a:lnSpc>
+              <a:buNone/>
+            </a:pPr>
+            <a:r>
+              <a:rPr lang="en-US" sz="1500" b="1" dirty="0">
+                <a:solidFill>
+                  <a:srgbClr val="E0E828"/>
+                </a:solidFill>
+              </a:rPr>
+              <a:t>01  소재</a:t>
+            </a:r>
+            <a:endParaRPr lang="en-US" sz="1500" dirty="0"/>
+          </a:p>
+          <a:p>
+            <a:pPr indent="0" marL="0">
+              <a:lnSpc>
+                <a:spcPct val="125000"/>
+              </a:lnSpc>
+              <a:buNone/>
+            </a:pPr>
+            <a:r>
+              <a:rPr lang="en-US" sz="1100" dirty="0">
+                <a:solidFill>
+                  <a:schemeClr val="bg1"/>
+                </a:solidFill>
+              </a:rPr>
+              <a:t>실크벽지 PVC · 폐타이어 고무 · CXP 목재 복합소재</a:t>
+            </a:r>
+            <a:endParaRPr lang="en-US" sz="1500" dirty="0"/>
+          </a:p>
+        </p:txBody>
+      </p:sp>
+      <p:sp>
+        <p:nvSpPr>
+          <p:cNvPr id="6" name="역량 카드"/>
+          <p:cNvSpPr/>
+          <p:nvPr/>
+        </p:nvSpPr>
+        <p:spPr>
+          <a:xfrm>
+            <a:off x="4322978" y="1645920"/>
+            <a:ext cx="3545738" cy="1097280"/>
+          </a:xfrm>
+          <a:prstGeom prst="roundRect">
+            <a:avLst>
+              <a:gd name="adj" fmla="val 6667"/>
+            </a:avLst>
+          </a:prstGeom>
+          <a:solidFill>
+            <a:schemeClr val="accent5"/>
+          </a:solidFill>
+          <a:ln/>
+        </p:spPr>
+      </p:sp>
+      <p:sp>
+        <p:nvSpPr>
+          <p:cNvPr id="7" name="역량"/>
+          <p:cNvSpPr txBox="1"/>
+          <p:nvPr/>
+        </p:nvSpPr>
+        <p:spPr>
+          <a:xfrm>
+            <a:off x="4597298" y="1810512"/>
+            <a:ext cx="2997098" cy="822960"/>
+          </a:xfrm>
+          <a:prstGeom prst="rect">
+            <a:avLst/>
+          </a:prstGeom>
+          <a:noFill/>
+          <a:ln/>
+        </p:spPr>
+        <p:txBody>
+          <a:bodyPr wrap="square" lIns="0" tIns="0" rIns="0" bIns="0" rtlCol="0" anchor="t"/>
+          <a:lstStyle/>
+          <a:p>
+            <a:pPr indent="0" marL="0">
+              <a:lnSpc>
+                <a:spcPct val="125000"/>
+              </a:lnSpc>
+              <a:buNone/>
+            </a:pPr>
+            <a:r>
+              <a:rPr lang="en-US" sz="1500" b="1" dirty="0">
+                <a:solidFill>
+                  <a:srgbClr val="E0E828"/>
+                </a:solidFill>
+              </a:rPr>
+              <a:t>02  기획 · 설계</a:t>
+            </a:r>
+            <a:endParaRPr lang="en-US" sz="1500" dirty="0"/>
+          </a:p>
+          <a:p>
+            <a:pPr indent="0" marL="0">
+              <a:lnSpc>
+                <a:spcPct val="125000"/>
+              </a:lnSpc>
+              <a:buNone/>
+            </a:pPr>
+            <a:r>
+              <a:rPr lang="en-US" sz="1100" dirty="0">
+                <a:solidFill>
+                  <a:schemeClr val="bg1"/>
+                </a:solidFill>
+              </a:rPr>
+              <a:t>제품 디자인 · 금형 · 상표/특허 출원 · 라이선싱</a:t>
+            </a:r>
+            <a:endParaRPr lang="en-US" sz="1500" dirty="0"/>
+          </a:p>
+        </p:txBody>
+      </p:sp>
+      <p:sp>
+        <p:nvSpPr>
+          <p:cNvPr id="8" name="역량 카드"/>
+          <p:cNvSpPr/>
+          <p:nvPr/>
+        </p:nvSpPr>
+        <p:spPr>
+          <a:xfrm>
+            <a:off x="8051597" y="1645920"/>
+            <a:ext cx="3545738" cy="1097280"/>
+          </a:xfrm>
+          <a:prstGeom prst="roundRect">
+            <a:avLst>
+              <a:gd name="adj" fmla="val 6667"/>
+            </a:avLst>
+          </a:prstGeom>
+          <a:solidFill>
+            <a:schemeClr val="accent5"/>
+          </a:solidFill>
+          <a:ln/>
+        </p:spPr>
+      </p:sp>
+      <p:sp>
+        <p:nvSpPr>
+          <p:cNvPr id="9" name="역량"/>
+          <p:cNvSpPr txBox="1"/>
+          <p:nvPr/>
+        </p:nvSpPr>
+        <p:spPr>
+          <a:xfrm>
+            <a:off x="8325917" y="1810512"/>
+            <a:ext cx="2997098" cy="822960"/>
+          </a:xfrm>
+          <a:prstGeom prst="rect">
+            <a:avLst/>
+          </a:prstGeom>
+          <a:noFill/>
+          <a:ln/>
+        </p:spPr>
+        <p:txBody>
+          <a:bodyPr wrap="square" lIns="0" tIns="0" rIns="0" bIns="0" rtlCol="0" anchor="t"/>
+          <a:lstStyle/>
+          <a:p>
+            <a:pPr indent="0" marL="0">
+              <a:lnSpc>
+                <a:spcPct val="125000"/>
+              </a:lnSpc>
+              <a:buNone/>
+            </a:pPr>
+            <a:r>
+              <a:rPr lang="en-US" sz="1500" b="1" dirty="0">
+                <a:solidFill>
+                  <a:srgbClr val="E0E828"/>
+                </a:solidFill>
+              </a:rPr>
+              <a:t>03  생산 · 납품</a:t>
+            </a:r>
+            <a:endParaRPr lang="en-US" sz="1500" dirty="0"/>
+          </a:p>
+          <a:p>
+            <a:pPr indent="0" marL="0">
+              <a:lnSpc>
+                <a:spcPct val="125000"/>
+              </a:lnSpc>
+              <a:buNone/>
+            </a:pPr>
+            <a:r>
+              <a:rPr lang="en-US" sz="1100" dirty="0">
+                <a:solidFill>
+                  <a:schemeClr val="bg1"/>
+                </a:solidFill>
+              </a:rPr>
+              <a:t>국내 제조 · 대형 매장 전국 납품 · B2B/OEM</a:t>
+            </a:r>
+            <a:endParaRPr lang="en-US" sz="1500" dirty="0"/>
+          </a:p>
+        </p:txBody>
+      </p:sp>
+      <p:sp>
+        <p:nvSpPr>
+          <p:cNvPr id="10" name="Text 8"/>
+          <p:cNvSpPr txBox="1"/>
+          <p:nvPr/>
+        </p:nvSpPr>
+        <p:spPr>
+          <a:xfrm>
+            <a:off x="594360" y="3063240"/>
+            <a:ext cx="2743200" cy="256032"/>
+          </a:xfrm>
+          <a:prstGeom prst="rect">
+            <a:avLst/>
+          </a:prstGeom>
+          <a:noFill/>
+          <a:ln/>
+        </p:spPr>
+        <p:txBody>
+          <a:bodyPr wrap="square" lIns="0" tIns="0" rIns="0" bIns="0" rtlCol="0" anchor="t"/>
+          <a:lstStyle/>
+          <a:p>
+            <a:pPr indent="0" marL="0">
+              <a:buNone/>
+            </a:pPr>
+            <a:r>
+              <a:rPr lang="en-US" sz="1000" b="1" spc="400" kern="0" dirty="0">
+                <a:solidFill>
+                  <a:srgbClr val="E0E828"/>
+                </a:solidFill>
+              </a:rPr>
+              <a:t>HISTORY</a:t>
+            </a:r>
+            <a:endParaRPr lang="en-US" sz="1000" dirty="0"/>
+          </a:p>
+        </p:txBody>
+      </p:sp>
+      <p:sp>
+        <p:nvSpPr>
+          <p:cNvPr id="11" name="타임라인"/>
+          <p:cNvSpPr/>
+          <p:nvPr/>
+        </p:nvSpPr>
+        <p:spPr>
+          <a:xfrm>
+            <a:off x="594360" y="3566160"/>
+            <a:ext cx="6903720" cy="0"/>
+          </a:xfrm>
+          <a:prstGeom prst="line">
+            <a:avLst/>
+          </a:prstGeom>
+          <a:noFill/>
+          <a:ln w="25400">
+            <a:solidFill>
+              <a:srgbClr val="4B46B0"/>
+            </a:solidFill>
+            <a:prstDash val="solid"/>
+          </a:ln>
+        </p:spPr>
+      </p:sp>
+      <p:sp>
+        <p:nvSpPr>
+          <p:cNvPr id="12" name="연혁 점"/>
+          <p:cNvSpPr/>
+          <p:nvPr/>
+        </p:nvSpPr>
+        <p:spPr>
+          <a:xfrm>
+            <a:off x="594360" y="3438144"/>
+            <a:ext cx="256032" cy="256032"/>
+          </a:xfrm>
+          <a:prstGeom prst="ellipse">
+            <a:avLst/>
+          </a:prstGeom>
+          <a:solidFill>
+            <a:schemeClr val="accent3"/>
+          </a:solidFill>
+          <a:ln/>
+        </p:spPr>
+      </p:sp>
+      <p:sp>
+        <p:nvSpPr>
+          <p:cNvPr id="13" name="Text 11"/>
+          <p:cNvSpPr txBox="1"/>
+          <p:nvPr/>
+        </p:nvSpPr>
+        <p:spPr>
+          <a:xfrm>
+            <a:off x="594360" y="3840480"/>
+            <a:ext cx="1623060" cy="411480"/>
+          </a:xfrm>
+          <a:prstGeom prst="rect">
+            <a:avLst/>
+          </a:prstGeom>
+          <a:noFill/>
+          <a:ln/>
+        </p:spPr>
+        <p:txBody>
+          <a:bodyPr wrap="square" lIns="0" tIns="0" rIns="0" bIns="0" rtlCol="0" anchor="t"/>
+          <a:lstStyle/>
+          <a:p>
+            <a:pPr indent="0" marL="0">
+              <a:buNone/>
+            </a:pPr>
+            <a:r>
+              <a:rPr lang="en-US" sz="2000" b="1" dirty="0">
+                <a:solidFill>
+                  <a:schemeClr val="bg1"/>
+                </a:solidFill>
+              </a:rPr>
+              <a:t>2023</a:t>
+            </a:r>
+            <a:endParaRPr lang="en-US" sz="2000" dirty="0"/>
+          </a:p>
+        </p:txBody>
+      </p:sp>
+      <p:sp>
+        <p:nvSpPr>
+          <p:cNvPr id="14" name="연혁 2023"/>
+          <p:cNvSpPr txBox="1"/>
+          <p:nvPr/>
+        </p:nvSpPr>
+        <p:spPr>
+          <a:xfrm>
+            <a:off x="594360" y="4343400"/>
+            <a:ext cx="1623060" cy="1463040"/>
+          </a:xfrm>
+          <a:prstGeom prst="rect">
+            <a:avLst/>
+          </a:prstGeom>
+          <a:noFill/>
+          <a:ln/>
+        </p:spPr>
+        <p:txBody>
+          <a:bodyPr wrap="square" lIns="0" tIns="0" rIns="0" bIns="0" rtlCol="0" anchor="t"/>
+          <a:lstStyle/>
+          <a:p>
+            <a:pPr indent="0" marL="0">
+              <a:lnSpc>
+                <a:spcPct val="135000"/>
+              </a:lnSpc>
+              <a:buNone/>
+            </a:pPr>
+            <a:r>
+              <a:rPr lang="en-US" sz="1000" dirty="0">
+                <a:solidFill>
+                  <a:schemeClr val="bg2"/>
+                </a:solidFill>
+              </a:rPr>
+              <a:t>창업진흥원 국가과제</a:t>
+            </a:r>
+            <a:endParaRPr lang="en-US" sz="1000" dirty="0"/>
+          </a:p>
+          <a:p>
+            <a:pPr indent="0" marL="0">
+              <a:lnSpc>
+                <a:spcPct val="135000"/>
+              </a:lnSpc>
+              <a:buNone/>
+            </a:pPr>
+            <a:r>
+              <a:rPr lang="en-US" sz="1000" dirty="0">
+                <a:solidFill>
+                  <a:schemeClr val="bg2"/>
+                </a:solidFill>
+              </a:rPr>
+              <a:t>㈜알앤디메이커스 창립</a:t>
+            </a:r>
+            <a:endParaRPr lang="en-US" sz="1000" dirty="0"/>
+          </a:p>
+          <a:p>
+            <a:pPr indent="0" marL="0">
+              <a:lnSpc>
+                <a:spcPct val="135000"/>
+              </a:lnSpc>
+              <a:buNone/>
+            </a:pPr>
+            <a:r>
+              <a:rPr lang="en-US" sz="1000" dirty="0">
+                <a:solidFill>
+                  <a:schemeClr val="bg2"/>
+                </a:solidFill>
+              </a:rPr>
+              <a:t>다이소 전국 매장 입점</a:t>
+            </a:r>
+            <a:endParaRPr lang="en-US" sz="1000" dirty="0"/>
+          </a:p>
+        </p:txBody>
+      </p:sp>
+      <p:sp>
+        <p:nvSpPr>
+          <p:cNvPr id="15" name="연혁 점"/>
+          <p:cNvSpPr/>
+          <p:nvPr/>
+        </p:nvSpPr>
+        <p:spPr>
+          <a:xfrm>
+            <a:off x="2354580" y="3438144"/>
+            <a:ext cx="256032" cy="256032"/>
+          </a:xfrm>
+          <a:prstGeom prst="ellipse">
+            <a:avLst/>
+          </a:prstGeom>
+          <a:solidFill>
+            <a:schemeClr val="accent3"/>
+          </a:solidFill>
+          <a:ln/>
+        </p:spPr>
+      </p:sp>
+      <p:sp>
+        <p:nvSpPr>
+          <p:cNvPr id="16" name="Text 14"/>
+          <p:cNvSpPr txBox="1"/>
+          <p:nvPr/>
+        </p:nvSpPr>
+        <p:spPr>
+          <a:xfrm>
+            <a:off x="2354580" y="3840480"/>
+            <a:ext cx="1623060" cy="411480"/>
+          </a:xfrm>
+          <a:prstGeom prst="rect">
+            <a:avLst/>
+          </a:prstGeom>
+          <a:noFill/>
+          <a:ln/>
+        </p:spPr>
+        <p:txBody>
+          <a:bodyPr wrap="square" lIns="0" tIns="0" rIns="0" bIns="0" rtlCol="0" anchor="t"/>
+          <a:lstStyle/>
+          <a:p>
+            <a:pPr indent="0" marL="0">
+              <a:buNone/>
+            </a:pPr>
+            <a:r>
+              <a:rPr lang="en-US" sz="2000" b="1" dirty="0">
+                <a:solidFill>
+                  <a:schemeClr val="bg1"/>
+                </a:solidFill>
+              </a:rPr>
+              <a:t>2024</a:t>
+            </a:r>
+            <a:endParaRPr lang="en-US" sz="2000" dirty="0"/>
+          </a:p>
+        </p:txBody>
+      </p:sp>
+      <p:sp>
+        <p:nvSpPr>
+          <p:cNvPr id="17" name="연혁 2024"/>
+          <p:cNvSpPr txBox="1"/>
+          <p:nvPr/>
+        </p:nvSpPr>
+        <p:spPr>
+          <a:xfrm>
+            <a:off x="2354580" y="4343400"/>
+            <a:ext cx="1623060" cy="1463040"/>
+          </a:xfrm>
+          <a:prstGeom prst="rect">
+            <a:avLst/>
+          </a:prstGeom>
+          <a:noFill/>
+          <a:ln/>
+        </p:spPr>
+        <p:txBody>
+          <a:bodyPr wrap="square" lIns="0" tIns="0" rIns="0" bIns="0" rtlCol="0" anchor="t"/>
+          <a:lstStyle/>
+          <a:p>
+            <a:pPr indent="0" marL="0">
+              <a:lnSpc>
+                <a:spcPct val="135000"/>
+              </a:lnSpc>
+              <a:buNone/>
+            </a:pPr>
+            <a:r>
+              <a:rPr lang="en-US" sz="1000" dirty="0">
+                <a:solidFill>
+                  <a:schemeClr val="bg2"/>
+                </a:solidFill>
+              </a:rPr>
+              <a:t>환경부 새활용</a:t>
+            </a:r>
+            <a:endParaRPr lang="en-US" sz="1000" dirty="0"/>
+          </a:p>
+          <a:p>
+            <a:pPr indent="0" marL="0">
+              <a:lnSpc>
+                <a:spcPct val="135000"/>
+              </a:lnSpc>
+              <a:buNone/>
+            </a:pPr>
+            <a:r>
+              <a:rPr lang="en-US" sz="1000" dirty="0">
+                <a:solidFill>
+                  <a:schemeClr val="bg2"/>
+                </a:solidFill>
+              </a:rPr>
+              <a:t>지원사업 수행</a:t>
+            </a:r>
+            <a:endParaRPr lang="en-US" sz="1000" dirty="0"/>
+          </a:p>
+          <a:p>
+            <a:pPr indent="0" marL="0">
+              <a:lnSpc>
+                <a:spcPct val="135000"/>
+              </a:lnSpc>
+              <a:buNone/>
+            </a:pPr>
+            <a:r>
+              <a:rPr lang="en-US" sz="1000" dirty="0">
+                <a:solidFill>
+                  <a:schemeClr val="bg2"/>
+                </a:solidFill>
+              </a:rPr>
+              <a:t>오피스디포·오피스웨이</a:t>
+            </a:r>
+            <a:endParaRPr lang="en-US" sz="1000" dirty="0"/>
+          </a:p>
+          <a:p>
+            <a:pPr indent="0" marL="0">
+              <a:lnSpc>
+                <a:spcPct val="135000"/>
+              </a:lnSpc>
+              <a:buNone/>
+            </a:pPr>
+            <a:r>
+              <a:rPr lang="en-US" sz="1000" dirty="0">
+                <a:solidFill>
+                  <a:schemeClr val="bg2"/>
+                </a:solidFill>
+              </a:rPr>
+              <a:t>중국 첫 수출</a:t>
+            </a:r>
+            <a:endParaRPr lang="en-US" sz="1000" dirty="0"/>
+          </a:p>
+        </p:txBody>
+      </p:sp>
+      <p:sp>
+        <p:nvSpPr>
+          <p:cNvPr id="18" name="연혁 점"/>
+          <p:cNvSpPr/>
+          <p:nvPr/>
+        </p:nvSpPr>
+        <p:spPr>
+          <a:xfrm>
+            <a:off x="4114800" y="3438144"/>
+            <a:ext cx="256032" cy="256032"/>
+          </a:xfrm>
+          <a:prstGeom prst="ellipse">
+            <a:avLst/>
+          </a:prstGeom>
+          <a:solidFill>
+            <a:schemeClr val="accent3"/>
+          </a:solidFill>
+          <a:ln/>
+        </p:spPr>
+      </p:sp>
+      <p:sp>
+        <p:nvSpPr>
+          <p:cNvPr id="19" name="Text 17"/>
+          <p:cNvSpPr txBox="1"/>
+          <p:nvPr/>
+        </p:nvSpPr>
+        <p:spPr>
+          <a:xfrm>
+            <a:off x="4114800" y="3840480"/>
+            <a:ext cx="1623060" cy="411480"/>
+          </a:xfrm>
+          <a:prstGeom prst="rect">
+            <a:avLst/>
+          </a:prstGeom>
+          <a:noFill/>
+          <a:ln/>
+        </p:spPr>
+        <p:txBody>
+          <a:bodyPr wrap="square" lIns="0" tIns="0" rIns="0" bIns="0" rtlCol="0" anchor="t"/>
+          <a:lstStyle/>
+          <a:p>
+            <a:pPr indent="0" marL="0">
+              <a:buNone/>
+            </a:pPr>
+            <a:r>
+              <a:rPr lang="en-US" sz="2000" b="1" dirty="0">
+                <a:solidFill>
+                  <a:schemeClr val="bg1"/>
+                </a:solidFill>
+              </a:rPr>
+              <a:t>2025</a:t>
+            </a:r>
+            <a:endParaRPr lang="en-US" sz="2000" dirty="0"/>
+          </a:p>
+        </p:txBody>
+      </p:sp>
+      <p:sp>
+        <p:nvSpPr>
+          <p:cNvPr id="20" name="연혁 2025"/>
+          <p:cNvSpPr txBox="1"/>
+          <p:nvPr/>
+        </p:nvSpPr>
+        <p:spPr>
+          <a:xfrm>
+            <a:off x="4114800" y="4343400"/>
+            <a:ext cx="1623060" cy="1463040"/>
+          </a:xfrm>
+          <a:prstGeom prst="rect">
+            <a:avLst/>
+          </a:prstGeom>
+          <a:noFill/>
+          <a:ln/>
+        </p:spPr>
+        <p:txBody>
+          <a:bodyPr wrap="square" lIns="0" tIns="0" rIns="0" bIns="0" rtlCol="0" anchor="t"/>
+          <a:lstStyle/>
+          <a:p>
+            <a:pPr indent="0" marL="0">
+              <a:lnSpc>
+                <a:spcPct val="135000"/>
+              </a:lnSpc>
+              <a:buNone/>
+            </a:pPr>
+            <a:r>
+              <a:rPr lang="en-US" sz="1000" dirty="0">
+                <a:solidFill>
+                  <a:schemeClr val="bg2"/>
+                </a:solidFill>
+              </a:rPr>
+              <a:t>상표권·BM 특허 출원</a:t>
+            </a:r>
+            <a:endParaRPr lang="en-US" sz="1000" dirty="0"/>
+          </a:p>
+          <a:p>
+            <a:pPr indent="0" marL="0">
+              <a:lnSpc>
+                <a:spcPct val="135000"/>
+              </a:lnSpc>
+              <a:buNone/>
+            </a:pPr>
+            <a:r>
+              <a:rPr lang="en-US" sz="1000" dirty="0">
+                <a:solidFill>
+                  <a:schemeClr val="bg2"/>
+                </a:solidFill>
+              </a:rPr>
+              <a:t>꿈돌이 라이선싱</a:t>
+            </a:r>
+            <a:endParaRPr lang="en-US" sz="1000" dirty="0"/>
+          </a:p>
+          <a:p>
+            <a:pPr indent="0" marL="0">
+              <a:lnSpc>
+                <a:spcPct val="135000"/>
+              </a:lnSpc>
+              <a:buNone/>
+            </a:pPr>
+            <a:r>
+              <a:rPr lang="en-US" sz="1000" dirty="0">
+                <a:solidFill>
+                  <a:schemeClr val="bg2"/>
+                </a:solidFill>
+              </a:rPr>
+              <a:t>롯데패키징앤솔루션</a:t>
+            </a:r>
+            <a:endParaRPr lang="en-US" sz="1000" dirty="0"/>
+          </a:p>
+          <a:p>
+            <a:pPr indent="0" marL="0">
+              <a:lnSpc>
+                <a:spcPct val="135000"/>
+              </a:lnSpc>
+              <a:buNone/>
+            </a:pPr>
+            <a:r>
+              <a:rPr lang="en-US" sz="1000" dirty="0">
+                <a:solidFill>
+                  <a:schemeClr val="bg2"/>
+                </a:solidFill>
+              </a:rPr>
+              <a:t>· 서브원 납품</a:t>
+            </a:r>
+            <a:endParaRPr lang="en-US" sz="1000" dirty="0"/>
+          </a:p>
+        </p:txBody>
+      </p:sp>
+      <p:sp>
+        <p:nvSpPr>
+          <p:cNvPr id="21" name="연혁 점"/>
+          <p:cNvSpPr/>
+          <p:nvPr/>
+        </p:nvSpPr>
+        <p:spPr>
+          <a:xfrm>
+            <a:off x="5875020" y="3438144"/>
+            <a:ext cx="256032" cy="256032"/>
+          </a:xfrm>
+          <a:prstGeom prst="ellipse">
+            <a:avLst/>
+          </a:prstGeom>
+          <a:solidFill>
+            <a:srgbClr val="C6F432"/>
+          </a:solidFill>
+          <a:ln/>
+        </p:spPr>
+      </p:sp>
+      <p:sp>
+        <p:nvSpPr>
+          <p:cNvPr id="22" name="Text 20"/>
+          <p:cNvSpPr txBox="1"/>
+          <p:nvPr/>
+        </p:nvSpPr>
+        <p:spPr>
+          <a:xfrm>
+            <a:off x="5875020" y="3840480"/>
+            <a:ext cx="1623060" cy="411480"/>
+          </a:xfrm>
+          <a:prstGeom prst="rect">
+            <a:avLst/>
+          </a:prstGeom>
+          <a:noFill/>
+          <a:ln/>
+        </p:spPr>
+        <p:txBody>
+          <a:bodyPr wrap="square" lIns="0" tIns="0" rIns="0" bIns="0" rtlCol="0" anchor="t"/>
+          <a:lstStyle/>
+          <a:p>
+            <a:pPr indent="0" marL="0">
+              <a:buNone/>
+            </a:pPr>
+            <a:r>
+              <a:rPr lang="en-US" sz="2000" b="1" dirty="0">
+                <a:solidFill>
+                  <a:srgbClr val="E0E828"/>
+                </a:solidFill>
+              </a:rPr>
+              <a:t>2026</a:t>
+            </a:r>
+            <a:endParaRPr lang="en-US" sz="2000" dirty="0"/>
+          </a:p>
+        </p:txBody>
+      </p:sp>
+      <p:sp>
+        <p:nvSpPr>
+          <p:cNvPr id="23" name="연혁 2026"/>
+          <p:cNvSpPr txBox="1"/>
+          <p:nvPr/>
+        </p:nvSpPr>
+        <p:spPr>
+          <a:xfrm>
+            <a:off x="5875020" y="4343400"/>
+            <a:ext cx="1623060" cy="1463040"/>
+          </a:xfrm>
+          <a:prstGeom prst="rect">
+            <a:avLst/>
+          </a:prstGeom>
+          <a:noFill/>
+          <a:ln/>
+        </p:spPr>
+        <p:txBody>
+          <a:bodyPr wrap="square" lIns="0" tIns="0" rIns="0" bIns="0" rtlCol="0" anchor="t"/>
+          <a:lstStyle/>
+          <a:p>
+            <a:pPr indent="0" marL="0">
+              <a:lnSpc>
+                <a:spcPct val="135000"/>
+              </a:lnSpc>
+              <a:buNone/>
+            </a:pPr>
+            <a:r>
+              <a:rPr lang="en-US" sz="1000" b="1" dirty="0">
+                <a:solidFill>
+                  <a:srgbClr val="E0E828"/>
+                </a:solidFill>
+              </a:rPr>
+              <a:t>환경부 새활용</a:t>
+            </a:r>
+            <a:endParaRPr lang="en-US" sz="1000" dirty="0"/>
+          </a:p>
+          <a:p>
+            <a:pPr indent="0" marL="0">
+              <a:lnSpc>
+                <a:spcPct val="135000"/>
+              </a:lnSpc>
+              <a:buNone/>
+            </a:pPr>
+            <a:r>
+              <a:rPr lang="en-US" sz="1000" b="1" dirty="0">
+                <a:solidFill>
+                  <a:srgbClr val="E0E828"/>
+                </a:solidFill>
+              </a:rPr>
+              <a:t>지원사업 2차</a:t>
+            </a:r>
+            <a:endParaRPr lang="en-US" sz="1000" dirty="0"/>
+          </a:p>
+          <a:p>
+            <a:pPr indent="0" marL="0">
+              <a:lnSpc>
+                <a:spcPct val="135000"/>
+              </a:lnSpc>
+              <a:buNone/>
+            </a:pPr>
+            <a:r>
+              <a:rPr lang="en-US" sz="1000" b="1" dirty="0">
+                <a:solidFill>
+                  <a:srgbClr val="E0E828"/>
+                </a:solidFill>
+              </a:rPr>
+              <a:t>라라슈 브랜드 런칭</a:t>
+            </a:r>
+            <a:endParaRPr lang="en-US" sz="1000" dirty="0"/>
+          </a:p>
+        </p:txBody>
+      </p:sp>
+      <p:sp>
+        <p:nvSpPr>
+          <p:cNvPr id="24" name="상담 박스"/>
+          <p:cNvSpPr/>
+          <p:nvPr/>
+        </p:nvSpPr>
+        <p:spPr>
+          <a:xfrm>
+            <a:off x="7863840" y="3063240"/>
+            <a:ext cx="3733495" cy="2423160"/>
+          </a:xfrm>
+          <a:prstGeom prst="roundRect">
+            <a:avLst>
+              <a:gd name="adj" fmla="val 3774"/>
             </a:avLst>
           </a:prstGeom>
           <a:solidFill>
@@ -4256,14 +4401,14 @@
       </p:sp>
       <p:sp>
         <p:nvSpPr>
-          <p:cNvPr id="11" name="Text 9"/>
+          <p:cNvPr id="25" name="Text 23"/>
           <p:cNvSpPr txBox="1"/>
           <p:nvPr/>
         </p:nvSpPr>
         <p:spPr>
           <a:xfrm>
-            <a:off x="6995160" y="2057400"/>
-            <a:ext cx="4297680" cy="731520"/>
+            <a:off x="8138160" y="3246120"/>
+            <a:ext cx="3291840" cy="365760"/>
           </a:xfrm>
           <a:prstGeom prst="rect">
             <a:avLst/>
@@ -4279,41 +4424,27 @@
               <a:buNone/>
             </a:pPr>
             <a:r>
-              <a:rPr lang="en-US" sz="1800" b="1" dirty="0">
+              <a:rPr lang="en-US" sz="1500" b="1" dirty="0">
                 <a:solidFill>
                   <a:srgbClr val="181478"/>
                 </a:solidFill>
               </a:rPr>
               <a:t>B2B · OEM/ODM · 납품 상담</a:t>
             </a:r>
-            <a:endParaRPr lang="en-US" sz="1800" dirty="0"/>
-          </a:p>
-          <a:p>
-            <a:pPr indent="0" marL="0">
-              <a:buNone/>
-            </a:pPr>
-            <a:r>
-              <a:rPr lang="en-US" sz="1150" dirty="0">
-                <a:solidFill>
-                  <a:srgbClr val="181478"/>
-                </a:solidFill>
-              </a:rPr>
-              <a:t>단체 공급 · 자체 브랜드 OEM · 소재 ODM</a:t>
-            </a:r>
-            <a:endParaRPr lang="en-US" sz="1800" dirty="0"/>
-          </a:p>
-        </p:txBody>
-      </p:sp>
-      <p:sp>
-        <p:nvSpPr>
-          <p:cNvPr id="12" name="연락처"/>
+            <a:endParaRPr lang="en-US" sz="1500" dirty="0"/>
+          </a:p>
+        </p:txBody>
+      </p:sp>
+      <p:sp>
+        <p:nvSpPr>
+          <p:cNvPr id="26" name="연락처"/>
           <p:cNvSpPr txBox="1"/>
           <p:nvPr/>
         </p:nvSpPr>
         <p:spPr>
           <a:xfrm>
-            <a:off x="6995160" y="3063240"/>
-            <a:ext cx="2743200" cy="1828800"/>
+            <a:off x="8138160" y="3749040"/>
+            <a:ext cx="2286000" cy="1737360"/>
           </a:xfrm>
           <a:prstGeom prst="rect">
             <a:avLst/>
@@ -4332,14 +4463,14 @@
               <a:buNone/>
             </a:pPr>
             <a:r>
-              <a:rPr lang="en-US" sz="1200" b="1" dirty="0">
+              <a:rPr lang="en-US" sz="1050" b="1" dirty="0">
                 <a:solidFill>
                   <a:srgbClr val="181478"/>
                 </a:solidFill>
               </a:rPr>
               <a:t>㈜알앤디메이커스  신동규 대표</a:t>
             </a:r>
-            <a:endParaRPr lang="en-US" sz="1200" dirty="0"/>
+            <a:endParaRPr lang="en-US" sz="1050" dirty="0"/>
           </a:p>
           <a:p>
             <a:pPr indent="0" marL="0">
@@ -4349,14 +4480,14 @@
               <a:buNone/>
             </a:pPr>
             <a:r>
-              <a:rPr lang="en-US" sz="1200" dirty="0">
+              <a:rPr lang="en-US" sz="1050" dirty="0">
                 <a:solidFill>
                   <a:srgbClr val="181478"/>
                 </a:solidFill>
               </a:rPr>
               <a:t>대전시 유성구 국제과학7로 8</a:t>
             </a:r>
-            <a:endParaRPr lang="en-US" sz="1200" dirty="0"/>
+            <a:endParaRPr lang="en-US" sz="1050" dirty="0"/>
           </a:p>
           <a:p>
             <a:pPr indent="0" marL="0">
@@ -4366,14 +4497,14 @@
               <a:buNone/>
             </a:pPr>
             <a:r>
-              <a:rPr lang="en-US" sz="1200" dirty="0">
+              <a:rPr lang="en-US" sz="1050" dirty="0">
                 <a:solidFill>
                   <a:srgbClr val="181478"/>
                 </a:solidFill>
               </a:rPr>
               <a:t>T  010-6880-2516</a:t>
             </a:r>
-            <a:endParaRPr lang="en-US" sz="1200" dirty="0"/>
+            <a:endParaRPr lang="en-US" sz="1050" dirty="0"/>
           </a:p>
           <a:p>
             <a:pPr indent="0" marL="0">
@@ -4383,14 +4514,14 @@
               <a:buNone/>
             </a:pPr>
             <a:r>
-              <a:rPr lang="en-US" sz="1200" dirty="0">
+              <a:rPr lang="en-US" sz="1050" dirty="0">
                 <a:solidFill>
                   <a:srgbClr val="181478"/>
                 </a:solidFill>
               </a:rPr>
               <a:t>E  rndceo@rndmakers.kr</a:t>
             </a:r>
-            <a:endParaRPr lang="en-US" sz="1200" dirty="0"/>
+            <a:endParaRPr lang="en-US" sz="1050" dirty="0"/>
           </a:p>
           <a:p>
             <a:pPr indent="0" marL="0">
@@ -4400,20 +4531,20 @@
               <a:buNone/>
             </a:pPr>
             <a:r>
-              <a:rPr lang="en-US" sz="1200" dirty="0">
+              <a:rPr lang="en-US" sz="1050" dirty="0">
                 <a:solidFill>
                   <a:srgbClr val="181478"/>
                 </a:solidFill>
               </a:rPr>
               <a:t>www.rndmakers.kr</a:t>
             </a:r>
-            <a:endParaRPr lang="en-US" sz="1200" dirty="0"/>
+            <a:endParaRPr lang="en-US" sz="1050" dirty="0"/>
           </a:p>
         </p:txBody>
       </p:sp>
       <p:pic>
         <p:nvPicPr>
-          <p:cNvPr id="13" name="QR" descr="img/qr-deck.png">    </p:cNvPr>
+          <p:cNvPr id="27" name="QR" descr="img/qr-deck.png">    </p:cNvPr>
           <p:cNvPicPr>
             <a:picLocks noChangeAspect="1"/>
           </p:cNvPicPr>
@@ -4427,8 +4558,8 @@
         </p:blipFill>
         <p:spPr>
           <a:xfrm>
-            <a:off x="9921240" y="3108960"/>
-            <a:ext cx="1371600" cy="1371600"/>
+            <a:off x="10405872" y="3794760"/>
+            <a:ext cx="1005840" cy="1005840"/>
           </a:xfrm>
           <a:prstGeom prst="rect">
             <a:avLst/>
@@ -4437,14 +4568,14 @@
       </p:pic>
       <p:sp>
         <p:nvSpPr>
-          <p:cNvPr id="14" name="Text 11"/>
+          <p:cNvPr id="28" name="Text 25"/>
           <p:cNvSpPr txBox="1"/>
           <p:nvPr/>
         </p:nvSpPr>
         <p:spPr>
           <a:xfrm>
-            <a:off x="9692640" y="4526280"/>
-            <a:ext cx="1828800" cy="274320"/>
+            <a:off x="10222992" y="4846320"/>
+            <a:ext cx="1371600" cy="228600"/>
           </a:xfrm>
           <a:prstGeom prst="rect">
             <a:avLst/>
@@ -4460,14 +4591,14 @@
               <a:buNone/>
             </a:pPr>
             <a:r>
-              <a:rPr lang="en-US" sz="950" b="1" dirty="0">
+              <a:rPr lang="en-US" sz="850" b="1" dirty="0">
                 <a:solidFill>
                   <a:srgbClr val="181478"/>
                 </a:solidFill>
               </a:rPr>
-              <a:t>라라슈 오픈 알림</a:t>
-            </a:r>
-            <a:endParaRPr lang="en-US" sz="950" dirty="0"/>
+              <a:t>라라슈 알림</a:t>
+            </a:r>
+            <a:endParaRPr lang="en-US" sz="850" dirty="0"/>
           </a:p>
         </p:txBody>
       </p:sp>

</xml_diff>